<commit_message>
Add presentation language selection and fix chart readability
</commit_message>
<xml_diff>
--- a/artifacts/stage2-demo/Все презентации/Сторонний шаблон — демо.pptx
+++ b/artifacts/stage2-demo/Все презентации/Сторонний шаблон — демо.pptx
@@ -164,7 +164,7 @@
               <c:strCache>
                 <c:ptCount val="1"/>
                 <c:pt idx="0">
-                  <c:v>actual leads</c:v>
+                  <c:v>Лиды (факт)</c:v>
                 </c:pt>
               </c:strCache>
             </c:strRef>
@@ -180,16 +180,16 @@
               <c:strCache>
                 <c:ptCount val="4"/>
                 <c:pt idx="0">
-                  <c:v>Search</c:v>
+                  <c:v>Поиск</c:v>
                 </c:pt>
                 <c:pt idx="1">
-                  <c:v>Social</c:v>
+                  <c:v>Социальные сети</c:v>
                 </c:pt>
                 <c:pt idx="2">
-                  <c:v>Partners</c:v>
+                  <c:v>Партнёры</c:v>
                 </c:pt>
                 <c:pt idx="3">
-                  <c:v>Email</c:v>
+                  <c:v>Электронная почта</c:v>
                 </c:pt>
               </c:strCache>
             </c:strRef>
@@ -225,14 +225,14 @@
               <c:strCache>
                 <c:ptCount val="1"/>
                 <c:pt idx="0">
-                  <c:v>target leads</c:v>
+                  <c:v>Лиды (цель)</c:v>
                 </c:pt>
               </c:strCache>
             </c:strRef>
           </c:tx>
           <c:spPr>
             <a:solidFill>
-              <a:srgbClr val="14B8A6"/>
+              <a:srgbClr val="291E3E"/>
             </a:solidFill>
           </c:spPr>
           <c:cat>
@@ -241,16 +241,16 @@
               <c:strCache>
                 <c:ptCount val="4"/>
                 <c:pt idx="0">
-                  <c:v>Search</c:v>
+                  <c:v>Поиск</c:v>
                 </c:pt>
                 <c:pt idx="1">
-                  <c:v>Social</c:v>
+                  <c:v>Социальные сети</c:v>
                 </c:pt>
                 <c:pt idx="2">
-                  <c:v>Partners</c:v>
+                  <c:v>Партнёры</c:v>
                 </c:pt>
                 <c:pt idx="3">
-                  <c:v>Email</c:v>
+                  <c:v>Электронная почта</c:v>
                 </c:pt>
               </c:strCache>
             </c:strRef>
@@ -294,7 +294,7 @@
               <a:lstStyle/>
               <a:p>
                 <a:r>
-                  <a:t>channel</a:t>
+                  <a:t>Канал</a:t>
                 </a:r>
               </a:p>
             </c:rich>
@@ -342,7 +342,7 @@
               <a:lstStyle/>
               <a:p>
                 <a:r>
-                  <a:t>actual leads · target leads</a:t>
+                  <a:t>Лиды (факт) · Лиды (цель)</a:t>
                 </a:r>
               </a:p>
             </c:rich>
@@ -418,7 +418,7 @@
               <c:strCache>
                 <c:ptCount val="1"/>
                 <c:pt idx="0">
-                  <c:v>tickets</c:v>
+                  <c:v>Обращения</c:v>
                 </c:pt>
               </c:strCache>
             </c:strRef>
@@ -435,7 +435,7 @@
             <c:idx val="1"/>
             <c:spPr>
               <a:solidFill>
-                <a:srgbClr val="14B8A6"/>
+                <a:srgbClr val="291E3E"/>
               </a:solidFill>
             </c:spPr>
           </c:dPt>
@@ -443,23 +443,101 @@
             <c:idx val="2"/>
             <c:spPr>
               <a:solidFill>
-                <a:srgbClr val="EEF2F7"/>
+                <a:srgbClr val="9C78E2"/>
               </a:solidFill>
             </c:spPr>
           </c:dPt>
+          <c:dLbls>
+            <c:dLbl>
+              <c:idx val="0"/>
+              <c:spPr/>
+              <c:txPr>
+                <a:bodyPr/>
+                <a:lstStyle/>
+                <a:p>
+                  <a:pPr>
+                    <a:defRPr>
+                      <a:solidFill>
+                        <a:srgbClr val="FFFFFF"/>
+                      </a:solidFill>
+                    </a:defRPr>
+                  </a:pPr>
+                </a:p>
+              </c:txPr>
+              <c:showLegendKey val="0"/>
+              <c:showVal val="1"/>
+              <c:showCatName val="0"/>
+              <c:showSerName val="0"/>
+              <c:showPercent val="0"/>
+              <c:showBubbleSize val="0"/>
+            </c:dLbl>
+            <c:dLbl>
+              <c:idx val="1"/>
+              <c:spPr/>
+              <c:txPr>
+                <a:bodyPr/>
+                <a:lstStyle/>
+                <a:p>
+                  <a:pPr>
+                    <a:defRPr>
+                      <a:solidFill>
+                        <a:srgbClr val="FFFFFF"/>
+                      </a:solidFill>
+                    </a:defRPr>
+                  </a:pPr>
+                </a:p>
+              </c:txPr>
+              <c:showLegendKey val="0"/>
+              <c:showVal val="1"/>
+              <c:showCatName val="0"/>
+              <c:showSerName val="0"/>
+              <c:showPercent val="0"/>
+              <c:showBubbleSize val="0"/>
+            </c:dLbl>
+            <c:dLbl>
+              <c:idx val="2"/>
+              <c:spPr/>
+              <c:txPr>
+                <a:bodyPr/>
+                <a:lstStyle/>
+                <a:p>
+                  <a:pPr>
+                    <a:defRPr>
+                      <a:solidFill>
+                        <a:srgbClr val="000000"/>
+                      </a:solidFill>
+                    </a:defRPr>
+                  </a:pPr>
+                </a:p>
+              </c:txPr>
+              <c:showLegendKey val="0"/>
+              <c:showVal val="1"/>
+              <c:showCatName val="0"/>
+              <c:showSerName val="0"/>
+              <c:showPercent val="0"/>
+              <c:showBubbleSize val="0"/>
+            </c:dLbl>
+            <c:showLegendKey val="0"/>
+            <c:showVal val="0"/>
+            <c:showCatName val="0"/>
+            <c:showSerName val="0"/>
+            <c:showPercent val="0"/>
+            <c:showBubbleSize val="0"/>
+            <c:showLeaderLines val="1"/>
+          </c:dLbls>
           <c:cat>
             <c:strRef>
               <c:f>Sheet1!$A$2:$A$4</c:f>
               <c:strCache>
                 <c:ptCount val="3"/>
                 <c:pt idx="0">
-                  <c:v>Resolved</c:v>
+                  <c:v>Решено</c:v>
                 </c:pt>
                 <c:pt idx="1">
-                  <c:v>Pending</c:v>
+                  <c:v>В ожидании</c:v>
                 </c:pt>
                 <c:pt idx="2">
-                  <c:v>Escalated</c:v>
+                  <c:v>На эскалации</c:v>
                 </c:pt>
               </c:strCache>
             </c:strRef>
@@ -748,7 +826,7 @@
               <c:strCache>
                 <c:ptCount val="1"/>
                 <c:pt idx="0">
-                  <c:v>Requests</c:v>
+                  <c:v>Запросы</c:v>
                 </c:pt>
               </c:strCache>
             </c:strRef>
@@ -764,13 +842,13 @@
               <c:strCache>
                 <c:ptCount val="3"/>
                 <c:pt idx="0">
-                  <c:v>North</c:v>
+                  <c:v>Север</c:v>
                 </c:pt>
                 <c:pt idx="1">
-                  <c:v>Central</c:v>
+                  <c:v>Центр</c:v>
                 </c:pt>
                 <c:pt idx="2">
-                  <c:v>South</c:v>
+                  <c:v>Юг</c:v>
                 </c:pt>
               </c:strCache>
             </c:strRef>
@@ -811,7 +889,7 @@
               <a:lstStyle/>
               <a:p>
                 <a:r>
-                  <a:t>Region</a:t>
+                  <a:t>Регион</a:t>
                 </a:r>
               </a:p>
             </c:rich>
@@ -859,7 +937,7 @@
               <a:lstStyle/>
               <a:p>
                 <a:r>
-                  <a:t>Requests, шт.</a:t>
+                  <a:t>Запросы, шт.</a:t>
                 </a:r>
               </a:p>
             </c:rich>
@@ -1535,7 +1613,7 @@
           <a:lstStyle/>
           <a:p>
             <a:r>
-              <a:t>Добро пожаловать. Сегодня мы обсудим итоги учебного пилота и примем решения о следующих шагах.</a:t>
+              <a:t>Добро пожаловать. Сегодня мы обсудим итоги учебного пилота и определим следующие шаги.</a:t>
             </a:r>
           </a:p>
         </p:txBody>
@@ -1605,7 +1683,7 @@
           <a:lstStyle/>
           <a:p>
             <a:r>
-              <a:t>Обратим внимание, что без решений пилот не приведёт к практическим результатам.</a:t>
+              <a:t>Теперь ваша задача — рассмотреть итоги, оценить их значение для вашего решения и определить конкретные следующие шаги.</a:t>
             </a:r>
           </a:p>
         </p:txBody>
@@ -1675,7 +1753,7 @@
           <a:lstStyle/>
           <a:p>
             <a:r>
-              <a:t>Призыв к действию: давайте обсудим и зафиксируем следующие шаги.</a:t>
+              <a:t>Спасибо за внимание. Я готов ответить на ваши вопросы и обсудить следующие шаги.</a:t>
             </a:r>
           </a:p>
         </p:txBody>
@@ -4265,7 +4343,7 @@
           <a:lstStyle/>
           <a:p>
             <a:r>
-              <a:t>Подчеркнём, что данные синтетические и предназначены для учебного процесса.</a:t>
+              <a:t>Слайды с выводами по каждой теме уже готовы. Мы не будем их повторять, а сосредоточимся на их значении для вашего решения.</a:t>
             </a:r>
           </a:p>
         </p:txBody>
@@ -7308,7 +7386,7 @@
                 </a:solidFill>
                 <a:latin typeface="Play"/>
               </a:rPr>
-              <a:t>Итоги учебного пилота</a:t>
+              <a:t>Итоги учебного пилота: от наблюдений к решениям</a:t>
             </a:r>
           </a:p>
         </p:txBody>
@@ -7342,7 +7420,7 @@
                 </a:solidFill>
                 <a:latin typeface="Play"/>
               </a:rPr>
-              <a:t>Обсуждение результатов и определение дальнейших действий</a:t>
+              <a:t>Мы собрались, чтобы обсудить результаты учебного пилота и определить следующие шаги</a:t>
             </a:r>
           </a:p>
         </p:txBody>
@@ -7533,7 +7611,7 @@
                 </a:solidFill>
                 <a:latin typeface="Play"/>
               </a:rPr>
-              <a:t>actual leads: максимум 240 — «Search»</a:t>
+              <a:t>Лиды (факт): максимум 240 — «Поиск»</a:t>
             </a:r>
           </a:p>
         </p:txBody>
@@ -7567,7 +7645,7 @@
                 </a:solidFill>
                 <a:latin typeface="Play"/>
               </a:rPr>
-              <a:t>Среди 4 полных наблюдений по полю «actual_leads» максимальное значение 240: «Search».</a:t>
+              <a:t>Среди 4 полных наблюдений по полю «Лиды (факт)» максимальное значение 240: «Поиск».</a:t>
             </a:r>
           </a:p>
         </p:txBody>
@@ -7644,7 +7722,7 @@
                 </a:solidFill>
                 <a:latin typeface="Play"/>
               </a:rPr>
-              <a:t>Источник: category_comparison.csv · 4 исходных строк</a:t>
+              <a:t>Источник: category_comparison.csv</a:t>
             </a:r>
           </a:p>
           <a:p>
@@ -7769,7 +7847,7 @@
                 </a:solidFill>
                 <a:latin typeface="Play"/>
               </a:rPr>
-              <a:t>tickets: «Resolved» — 62.00% показанной суммы</a:t>
+              <a:t>Обращения: «Решено» — 62.00% показанной суммы</a:t>
             </a:r>
           </a:p>
         </p:txBody>
@@ -7803,7 +7881,7 @@
                 </a:solidFill>
                 <a:latin typeface="Play"/>
               </a:rPr>
-              <a:t>Максимальная доля: «Resolved», 620 из 1000 (62.00%, округлено до 2 знаков). Доли относятся только к показанным строкам. Структура показанной суммы: «Resolved»: 62.00%; «Pending»: 25.00%; «Escalated»: 13.00%.</a:t>
+              <a:t>Максимальная доля: «Решено», 620 из 1000 (62.00%, округлено до 2 знаков). Доли относятся только к показанным строкам. Структура показанной суммы: «Решено»: 62.00%; «В ожидании»: 25.00%; «На эскалации»: 13.00%.</a:t>
             </a:r>
           </a:p>
         </p:txBody>
@@ -7880,7 +7958,7 @@
                 </a:solidFill>
                 <a:latin typeface="Play"/>
               </a:rPr>
-              <a:t>Источник: category_shares.json · 3 исходных строк</a:t>
+              <a:t>Источник: category_shares.json</a:t>
             </a:r>
           </a:p>
           <a:p>
@@ -8116,7 +8194,7 @@
                 </a:solidFill>
                 <a:latin typeface="Play"/>
               </a:rPr>
-              <a:t>Источник: distribution.csv · 25 исходных строк</a:t>
+              <a:t>Источник: distribution.csv</a:t>
             </a:r>
           </a:p>
           <a:p>
@@ -8241,7 +8319,7 @@
                 </a:solidFill>
                 <a:latin typeface="Play"/>
               </a:rPr>
-              <a:t>Requests: максимум 120 — «North»</a:t>
+              <a:t>Запросы: максимум 120 — «Север»</a:t>
             </a:r>
           </a:p>
         </p:txBody>
@@ -8275,7 +8353,7 @@
                 </a:solidFill>
                 <a:latin typeface="Play"/>
               </a:rPr>
-              <a:t>Среди 3 полных наблюдений по полю «Requests» максимальное значение 120: «North».</a:t>
+              <a:t>Среди 3 полных наблюдений по полю «Запросы» максимальное значение 120: «Север».</a:t>
             </a:r>
           </a:p>
         </p:txBody>
@@ -8352,7 +8430,7 @@
                 </a:solidFill>
                 <a:latin typeface="Play"/>
               </a:rPr>
-              <a:t>Источник: embedded_table.md · # Regional service snapshot · Source: synthetic test data. Units: requests and resolved requests, counts for Apr…</a:t>
+              <a:t>Источник: embedded_table.md</a:t>
             </a:r>
           </a:p>
           <a:p>
@@ -8467,7 +8545,7 @@
                           </a:solidFill>
                           <a:latin typeface="Play"/>
                         </a:rPr>
-                        <a:t>period</a:t>
+                        <a:t>Период</a:t>
                       </a:r>
                     </a:p>
                   </a:txBody>
@@ -8489,7 +8567,7 @@
                           </a:solidFill>
                           <a:latin typeface="Play"/>
                         </a:rPr>
-                        <a:t>actual_units</a:t>
+                        <a:t>Количество (факт)</a:t>
                       </a:r>
                     </a:p>
                   </a:txBody>
@@ -8511,7 +8589,7 @@
                           </a:solidFill>
                           <a:latin typeface="Play"/>
                         </a:rPr>
-                        <a:t>planned_units</a:t>
+                        <a:t>Количество (план)</a:t>
                       </a:r>
                     </a:p>
                   </a:txBody>
@@ -8533,7 +8611,7 @@
                           </a:solidFill>
                           <a:latin typeface="Play"/>
                         </a:rPr>
-                        <a:t>note</a:t>
+                        <a:t>Примечание</a:t>
                       </a:r>
                     </a:p>
                   </a:txBody>
@@ -8554,7 +8632,7 @@
                         <a:rPr sz="1600">
                           <a:latin typeface="Play"/>
                         </a:rPr>
-                        <a:t>Week 1</a:t>
+                        <a:t>Неделя 1</a:t>
                       </a:r>
                     </a:p>
                   </a:txBody>
@@ -8611,7 +8689,7 @@
                         <a:rPr sz="1600">
                           <a:latin typeface="Play"/>
                         </a:rPr>
-                        <a:t>observed zero</a:t>
+                        <a:t>Наблюдаемое нулевое значение</a:t>
                       </a:r>
                     </a:p>
                   </a:txBody>
@@ -8632,7 +8710,7 @@
                         <a:rPr sz="1600">
                           <a:latin typeface="Play"/>
                         </a:rPr>
-                        <a:t>Week 2</a:t>
+                        <a:t>Неделя 2</a:t>
                       </a:r>
                     </a:p>
                   </a:txBody>
@@ -8683,7 +8761,7 @@
                         <a:rPr sz="1600">
                           <a:latin typeface="Play"/>
                         </a:rPr>
-                        <a:t>actual missing</a:t>
+                        <a:t>Факт отсутствует</a:t>
                       </a:r>
                     </a:p>
                   </a:txBody>
@@ -8702,7 +8780,7 @@
                         <a:rPr sz="1600">
                           <a:latin typeface="Play"/>
                         </a:rPr>
-                        <a:t>Week 3</a:t>
+                        <a:t>Неделя 3</a:t>
                       </a:r>
                     </a:p>
                   </a:txBody>
@@ -8759,7 +8837,7 @@
                         <a:rPr sz="1600">
                           <a:latin typeface="Play"/>
                         </a:rPr>
-                        <a:t>planned missing</a:t>
+                        <a:t>План отсутствует</a:t>
                       </a:r>
                     </a:p>
                   </a:txBody>
@@ -8780,7 +8858,7 @@
                         <a:rPr sz="1600">
                           <a:latin typeface="Play"/>
                         </a:rPr>
-                        <a:t>Week 4</a:t>
+                        <a:t>Неделя 4</a:t>
                       </a:r>
                     </a:p>
                   </a:txBody>
@@ -8831,7 +8909,7 @@
                         <a:rPr sz="1600">
                           <a:latin typeface="Play"/>
                         </a:rPr>
-                        <a:t>actual zero</a:t>
+                        <a:t>Фактическое значение равно нулю</a:t>
                       </a:r>
                     </a:p>
                   </a:txBody>
@@ -8984,7 +9062,7 @@
                 </a:solidFill>
                 <a:latin typeface="Play"/>
               </a:rPr>
-              <a:t>Источник: missing_zero.csv · 4 исходных строк</a:t>
+              <a:t>Источник: missing_zero.csv</a:t>
             </a:r>
           </a:p>
           <a:p>
@@ -8995,7 +9073,7 @@
                 </a:solidFill>
                 <a:latin typeface="Play"/>
               </a:rPr>
-              <a:t>Охват: страница 1/1; строки источника 2–5 из 4; пропуски показаны как в источнике.</a:t>
+              <a:t>Охват: 4 из 4 строк; исключено: 0. Страница 1/1.</a:t>
             </a:r>
           </a:p>
         </p:txBody>
@@ -9202,7 +9280,7 @@
                 </a:solidFill>
                 <a:latin typeface="Play"/>
               </a:rPr>
-              <a:t>Источник: reference_201.csv · 201 исходных строк</a:t>
+              <a:t>Источник: reference_201.csv</a:t>
             </a:r>
           </a:p>
           <a:p>
@@ -9213,7 +9291,7 @@
                 </a:solidFill>
                 <a:latin typeface="Play"/>
               </a:rPr>
-              <a:t>Всего 201 строк; полный постраничный показ — в приложении.</a:t>
+              <a:t>Охват: 201 из 201 строк; исключено: 0. Показано: 0.</a:t>
             </a:r>
           </a:p>
         </p:txBody>
@@ -9438,7 +9516,7 @@
                 </a:solidFill>
                 <a:latin typeface="Play"/>
               </a:rPr>
-              <a:t>Источник: time_series.xlsx · лист «Monthly revenue» · 6 исходных строк</a:t>
+              <a:t>Источник: time_series.xlsx · лист «Monthly revenue»</a:t>
             </a:r>
           </a:p>
           <a:p>
@@ -9545,7 +9623,7 @@
                 </a:solidFill>
                 <a:latin typeface="Play"/>
               </a:rPr>
-              <a:t>Пилот завершён, данные готовы к анализу</a:t>
+              <a:t>Данные пилота готовы к анализу</a:t>
             </a:r>
           </a:p>
         </p:txBody>
@@ -9579,7 +9657,7 @@
                 </a:solidFill>
                 <a:latin typeface="Play"/>
               </a:rPr>
-              <a:t>Завершение пилота — Учебный пилот завершён, все данные собраны.</a:t>
+              <a:t>Готовые слайды — По каждой теме из таблицы «Пакет данных» уже есть слайды с выводами</a:t>
             </a:r>
           </a:p>
         </p:txBody>
@@ -9613,7 +9691,7 @@
                 </a:solidFill>
                 <a:latin typeface="Play"/>
               </a:rPr>
-              <a:t>Синтетические данные — Все значения являются синтетическими, как указано в брифе.</a:t>
+              <a:t>Отдельные темы — Каждая метрика представлена на отдельном слайде</a:t>
             </a:r>
           </a:p>
         </p:txBody>
@@ -9647,7 +9725,7 @@
                 </a:solidFill>
                 <a:latin typeface="Play"/>
               </a:rPr>
-              <a:t>Готовность к анализу — Данные готовы к обсуждению и интерпретации.</a:t>
+              <a:t>Синтетические данные — Все значения в пилоте являются синтетическими</a:t>
             </a:r>
           </a:p>
         </p:txBody>
@@ -9724,7 +9802,7 @@
                 </a:solidFill>
                 <a:latin typeface="Play"/>
               </a:rPr>
-              <a:t>Бриф: Все значения синтетические.</a:t>
+              <a:t>Бриф: Слайды с выводами из таблицы «Пакет данных» уже готовы, по одному на тему.</a:t>
             </a:r>
           </a:p>
         </p:txBody>
@@ -9820,7 +9898,7 @@
                 </a:solidFill>
                 <a:latin typeface="Play"/>
               </a:rPr>
-              <a:t>Решения нужны для продолжения работы</a:t>
+              <a:t>Следующие шаги: от наблюдений к решениям</a:t>
             </a:r>
           </a:p>
         </p:txBody>
@@ -9854,7 +9932,7 @@
                 </a:solidFill>
                 <a:latin typeface="Play"/>
               </a:rPr>
-              <a:t>Необходимость решений — Требуется принять решения на основе итогов пилота.</a:t>
+              <a:t>Рассмотреть итоги — Изучите готовые слайды с выводами по каждой теме</a:t>
             </a:r>
           </a:p>
         </p:txBody>
@@ -9888,7 +9966,7 @@
                 </a:solidFill>
                 <a:latin typeface="Play"/>
               </a:rPr>
-              <a:t>Следующие шаги — Следующие шаги зависят от принятых решений.</a:t>
+              <a:t>Оценить значение — Определите, что эти итоги значат для вашего решения</a:t>
             </a:r>
           </a:p>
         </p:txBody>
@@ -9922,14 +10000,48 @@
                 </a:solidFill>
                 <a:latin typeface="Play"/>
               </a:rPr>
-              <a:t>Ответственность аудитории — Аудитория должна определить приоритеты дальнейшей работы.</a:t>
+              <a:t>Принять решения — Определите, какие решения нужны на основе данных</a:t>
             </a:r>
           </a:p>
         </p:txBody>
       </p:sp>
       <p:sp>
         <p:nvSpPr>
-          <p:cNvPr id="6" name="Rectangle 5"/>
+          <p:cNvPr id="6" name="TextBox 5"/>
+          <p:cNvSpPr txBox="1"/>
+          <p:nvPr/>
+        </p:nvSpPr>
+        <p:spPr>
+          <a:xfrm>
+            <a:off x="1219169" y="4320540"/>
+            <a:ext cx="9753356" cy="802386"/>
+          </a:xfrm>
+          <a:prstGeom prst="rect">
+            <a:avLst/>
+          </a:prstGeom>
+          <a:noFill/>
+        </p:spPr>
+        <p:txBody>
+          <a:bodyPr wrap="square">
+            <a:spAutoFit/>
+          </a:bodyPr>
+          <a:lstStyle/>
+          <a:p>
+            <a:r>
+              <a:rPr sz="1600" b="0">
+                <a:solidFill>
+                  <a:srgbClr val="162032"/>
+                </a:solidFill>
+                <a:latin typeface="Play"/>
+              </a:rPr>
+              <a:t>Следующие шаги — Зафиксируйте конкретные действия и сроки</a:t>
+            </a:r>
+          </a:p>
+        </p:txBody>
+      </p:sp>
+      <p:sp>
+        <p:nvSpPr>
+          <p:cNvPr id="7" name="Rectangle 6"/>
           <p:cNvSpPr/>
           <p:nvPr/>
         </p:nvSpPr>
@@ -9972,7 +10084,7 @@
       </p:sp>
       <p:sp>
         <p:nvSpPr>
-          <p:cNvPr id="7" name="TextBox 6"/>
+          <p:cNvPr id="8" name="TextBox 7"/>
           <p:cNvSpPr txBox="1"/>
           <p:nvPr/>
         </p:nvSpPr>
@@ -9999,14 +10111,14 @@
                 </a:solidFill>
                 <a:latin typeface="Play"/>
               </a:rPr>
-              <a:t>Бриф: какие решения нужны и следующие шаги.</a:t>
+              <a:t>Бриф: что эти итоги значат для решения аудитории, какие решения нужны и следующие шаги.</a:t>
             </a:r>
           </a:p>
         </p:txBody>
       </p:sp>
       <p:pic>
         <p:nvPicPr>
-          <p:cNvPr id="8" name="Picture 7" descr="local-logo.png"/>
+          <p:cNvPr id="9" name="Picture 8" descr="local-logo.png"/>
           <p:cNvPicPr>
             <a:picLocks noChangeAspect="1"/>
           </p:cNvPicPr>
@@ -10095,7 +10207,7 @@
                 </a:solidFill>
                 <a:latin typeface="Play"/>
               </a:rPr>
-              <a:t>Примем решения о следующих шагах</a:t>
+              <a:t>Готовы к обсуждению решений</a:t>
             </a:r>
           </a:p>
         </p:txBody>
@@ -10129,7 +10241,7 @@
                 </a:solidFill>
                 <a:latin typeface="Play"/>
               </a:rPr>
-              <a:t>Обсудим и зафиксируем приоритеты для продолжения работы</a:t>
+              <a:t>Пожалуйста, задайте вопросы по готовым слайдам и предложите следующие шаги</a:t>
             </a:r>
           </a:p>
         </p:txBody>
@@ -10308,7 +10420,7 @@
                           </a:solidFill>
                           <a:latin typeface="Play"/>
                         </a:rPr>
-                        <a:t>reference_id</a:t>
+                        <a:t>Код записи</a:t>
                       </a:r>
                     </a:p>
                   </a:txBody>
@@ -10330,7 +10442,7 @@
                           </a:solidFill>
                           <a:latin typeface="Play"/>
                         </a:rPr>
-                        <a:t>label</a:t>
+                        <a:t>Наименование</a:t>
                       </a:r>
                     </a:p>
                   </a:txBody>
@@ -10370,7 +10482,7 @@
                         <a:rPr sz="1600">
                           <a:latin typeface="Play"/>
                         </a:rPr>
-                        <a:t>Reference item 001</a:t>
+                        <a:t>Запись справочника 001</a:t>
                       </a:r>
                     </a:p>
                   </a:txBody>
@@ -10408,7 +10520,7 @@
                         <a:rPr sz="1600">
                           <a:latin typeface="Play"/>
                         </a:rPr>
-                        <a:t>Reference item 002</a:t>
+                        <a:t>Запись справочника 002</a:t>
                       </a:r>
                     </a:p>
                   </a:txBody>
@@ -10446,7 +10558,7 @@
                         <a:rPr sz="1600">
                           <a:latin typeface="Play"/>
                         </a:rPr>
-                        <a:t>Reference item 003</a:t>
+                        <a:t>Запись справочника 003</a:t>
                       </a:r>
                     </a:p>
                   </a:txBody>
@@ -10484,7 +10596,7 @@
                         <a:rPr sz="1600">
                           <a:latin typeface="Play"/>
                         </a:rPr>
-                        <a:t>Reference item 004</a:t>
+                        <a:t>Запись справочника 004</a:t>
                       </a:r>
                     </a:p>
                   </a:txBody>
@@ -10522,7 +10634,7 @@
                         <a:rPr sz="1600">
                           <a:latin typeface="Play"/>
                         </a:rPr>
-                        <a:t>Reference item 005</a:t>
+                        <a:t>Запись справочника 005</a:t>
                       </a:r>
                     </a:p>
                   </a:txBody>
@@ -10560,7 +10672,7 @@
                         <a:rPr sz="1600">
                           <a:latin typeface="Play"/>
                         </a:rPr>
-                        <a:t>Reference item 006</a:t>
+                        <a:t>Запись справочника 006</a:t>
                       </a:r>
                     </a:p>
                   </a:txBody>
@@ -10598,7 +10710,7 @@
                         <a:rPr sz="1600">
                           <a:latin typeface="Play"/>
                         </a:rPr>
-                        <a:t>Reference item 007</a:t>
+                        <a:t>Запись справочника 007</a:t>
                       </a:r>
                     </a:p>
                   </a:txBody>
@@ -10753,7 +10865,7 @@
                 </a:solidFill>
                 <a:latin typeface="Play"/>
               </a:rPr>
-              <a:t>Источник: reference_201.csv · 201 исходных строк</a:t>
+              <a:t>Источник: reference_201.csv</a:t>
             </a:r>
           </a:p>
           <a:p>
@@ -10764,7 +10876,7 @@
                 </a:solidFill>
                 <a:latin typeface="Play"/>
               </a:rPr>
-              <a:t>Охват: страница 1/29; строки источника 2–8 из 201; пропуски показаны как в источнике.</a:t>
+              <a:t>Охват: 201 из 201 строк; исключено: 0. Страница 1/29. Показано: 7.</a:t>
             </a:r>
           </a:p>
         </p:txBody>
@@ -10866,7 +10978,7 @@
                           </a:solidFill>
                           <a:latin typeface="Play"/>
                         </a:rPr>
-                        <a:t>reference_id</a:t>
+                        <a:t>Код записи</a:t>
                       </a:r>
                     </a:p>
                   </a:txBody>
@@ -10888,7 +11000,7 @@
                           </a:solidFill>
                           <a:latin typeface="Play"/>
                         </a:rPr>
-                        <a:t>label</a:t>
+                        <a:t>Наименование</a:t>
                       </a:r>
                     </a:p>
                   </a:txBody>
@@ -10928,7 +11040,7 @@
                         <a:rPr sz="1600">
                           <a:latin typeface="Play"/>
                         </a:rPr>
-                        <a:t>Reference item 008</a:t>
+                        <a:t>Запись справочника 008</a:t>
                       </a:r>
                     </a:p>
                   </a:txBody>
@@ -10966,7 +11078,7 @@
                         <a:rPr sz="1600">
                           <a:latin typeface="Play"/>
                         </a:rPr>
-                        <a:t>Reference item 009</a:t>
+                        <a:t>Запись справочника 009</a:t>
                       </a:r>
                     </a:p>
                   </a:txBody>
@@ -11004,7 +11116,7 @@
                         <a:rPr sz="1600">
                           <a:latin typeface="Play"/>
                         </a:rPr>
-                        <a:t>Reference item 010</a:t>
+                        <a:t>Запись справочника 010</a:t>
                       </a:r>
                     </a:p>
                   </a:txBody>
@@ -11042,7 +11154,7 @@
                         <a:rPr sz="1600">
                           <a:latin typeface="Play"/>
                         </a:rPr>
-                        <a:t>Reference item 011</a:t>
+                        <a:t>Запись справочника 011</a:t>
                       </a:r>
                     </a:p>
                   </a:txBody>
@@ -11080,7 +11192,7 @@
                         <a:rPr sz="1600">
                           <a:latin typeface="Play"/>
                         </a:rPr>
-                        <a:t>Reference item 012</a:t>
+                        <a:t>Запись справочника 012</a:t>
                       </a:r>
                     </a:p>
                   </a:txBody>
@@ -11118,7 +11230,7 @@
                         <a:rPr sz="1600">
                           <a:latin typeface="Play"/>
                         </a:rPr>
-                        <a:t>Reference item 013</a:t>
+                        <a:t>Запись справочника 013</a:t>
                       </a:r>
                     </a:p>
                   </a:txBody>
@@ -11156,7 +11268,7 @@
                         <a:rPr sz="1600">
                           <a:latin typeface="Play"/>
                         </a:rPr>
-                        <a:t>Reference item 014</a:t>
+                        <a:t>Запись справочника 014</a:t>
                       </a:r>
                     </a:p>
                   </a:txBody>
@@ -11311,7 +11423,7 @@
                 </a:solidFill>
                 <a:latin typeface="Play"/>
               </a:rPr>
-              <a:t>Источник: reference_201.csv · 201 исходных строк</a:t>
+              <a:t>Источник: reference_201.csv</a:t>
             </a:r>
           </a:p>
           <a:p>
@@ -11322,7 +11434,7 @@
                 </a:solidFill>
                 <a:latin typeface="Play"/>
               </a:rPr>
-              <a:t>Охват: страница 2/29; строки источника 9–15 из 201; пропуски показаны как в источнике.</a:t>
+              <a:t>Охват: 201 из 201 строк; исключено: 0. Страница 2/29. Показано: 7.</a:t>
             </a:r>
           </a:p>
         </p:txBody>
@@ -11424,7 +11536,7 @@
                           </a:solidFill>
                           <a:latin typeface="Play"/>
                         </a:rPr>
-                        <a:t>reference_id</a:t>
+                        <a:t>Код записи</a:t>
                       </a:r>
                     </a:p>
                   </a:txBody>
@@ -11446,7 +11558,7 @@
                           </a:solidFill>
                           <a:latin typeface="Play"/>
                         </a:rPr>
-                        <a:t>label</a:t>
+                        <a:t>Наименование</a:t>
                       </a:r>
                     </a:p>
                   </a:txBody>
@@ -11486,7 +11598,7 @@
                         <a:rPr sz="1600">
                           <a:latin typeface="Play"/>
                         </a:rPr>
-                        <a:t>Reference item 015</a:t>
+                        <a:t>Запись справочника 015</a:t>
                       </a:r>
                     </a:p>
                   </a:txBody>
@@ -11524,7 +11636,7 @@
                         <a:rPr sz="1600">
                           <a:latin typeface="Play"/>
                         </a:rPr>
-                        <a:t>Reference item 016</a:t>
+                        <a:t>Запись справочника 016</a:t>
                       </a:r>
                     </a:p>
                   </a:txBody>
@@ -11562,7 +11674,7 @@
                         <a:rPr sz="1600">
                           <a:latin typeface="Play"/>
                         </a:rPr>
-                        <a:t>Reference item 017</a:t>
+                        <a:t>Запись справочника 017</a:t>
                       </a:r>
                     </a:p>
                   </a:txBody>
@@ -11600,7 +11712,7 @@
                         <a:rPr sz="1600">
                           <a:latin typeface="Play"/>
                         </a:rPr>
-                        <a:t>Reference item 018</a:t>
+                        <a:t>Запись справочника 018</a:t>
                       </a:r>
                     </a:p>
                   </a:txBody>
@@ -11638,7 +11750,7 @@
                         <a:rPr sz="1600">
                           <a:latin typeface="Play"/>
                         </a:rPr>
-                        <a:t>Reference item 019</a:t>
+                        <a:t>Запись справочника 019</a:t>
                       </a:r>
                     </a:p>
                   </a:txBody>
@@ -11676,7 +11788,7 @@
                         <a:rPr sz="1600">
                           <a:latin typeface="Play"/>
                         </a:rPr>
-                        <a:t>Reference item 020</a:t>
+                        <a:t>Запись справочника 020</a:t>
                       </a:r>
                     </a:p>
                   </a:txBody>
@@ -11714,7 +11826,7 @@
                         <a:rPr sz="1600">
                           <a:latin typeface="Play"/>
                         </a:rPr>
-                        <a:t>Reference item 021</a:t>
+                        <a:t>Запись справочника 021</a:t>
                       </a:r>
                     </a:p>
                   </a:txBody>
@@ -11869,7 +11981,7 @@
                 </a:solidFill>
                 <a:latin typeface="Play"/>
               </a:rPr>
-              <a:t>Источник: reference_201.csv · 201 исходных строк</a:t>
+              <a:t>Источник: reference_201.csv</a:t>
             </a:r>
           </a:p>
           <a:p>
@@ -11880,7 +11992,7 @@
                 </a:solidFill>
                 <a:latin typeface="Play"/>
               </a:rPr>
-              <a:t>Охват: страница 3/29; строки источника 16–22 из 201; пропуски показаны как в источнике.</a:t>
+              <a:t>Охват: 201 из 201 строк; исключено: 0. Страница 3/29. Показано: 7.</a:t>
             </a:r>
           </a:p>
         </p:txBody>
@@ -11982,7 +12094,7 @@
                           </a:solidFill>
                           <a:latin typeface="Play"/>
                         </a:rPr>
-                        <a:t>reference_id</a:t>
+                        <a:t>Код записи</a:t>
                       </a:r>
                     </a:p>
                   </a:txBody>
@@ -12004,7 +12116,7 @@
                           </a:solidFill>
                           <a:latin typeface="Play"/>
                         </a:rPr>
-                        <a:t>label</a:t>
+                        <a:t>Наименование</a:t>
                       </a:r>
                     </a:p>
                   </a:txBody>
@@ -12044,7 +12156,7 @@
                         <a:rPr sz="1600">
                           <a:latin typeface="Play"/>
                         </a:rPr>
-                        <a:t>Reference item 022</a:t>
+                        <a:t>Запись справочника 022</a:t>
                       </a:r>
                     </a:p>
                   </a:txBody>
@@ -12082,7 +12194,7 @@
                         <a:rPr sz="1600">
                           <a:latin typeface="Play"/>
                         </a:rPr>
-                        <a:t>Reference item 023</a:t>
+                        <a:t>Запись справочника 023</a:t>
                       </a:r>
                     </a:p>
                   </a:txBody>
@@ -12120,7 +12232,7 @@
                         <a:rPr sz="1600">
                           <a:latin typeface="Play"/>
                         </a:rPr>
-                        <a:t>Reference item 024</a:t>
+                        <a:t>Запись справочника 024</a:t>
                       </a:r>
                     </a:p>
                   </a:txBody>
@@ -12158,7 +12270,7 @@
                         <a:rPr sz="1600">
                           <a:latin typeface="Play"/>
                         </a:rPr>
-                        <a:t>Reference item 025</a:t>
+                        <a:t>Запись справочника 025</a:t>
                       </a:r>
                     </a:p>
                   </a:txBody>
@@ -12196,7 +12308,7 @@
                         <a:rPr sz="1600">
                           <a:latin typeface="Play"/>
                         </a:rPr>
-                        <a:t>Reference item 026</a:t>
+                        <a:t>Запись справочника 026</a:t>
                       </a:r>
                     </a:p>
                   </a:txBody>
@@ -12234,7 +12346,7 @@
                         <a:rPr sz="1600">
                           <a:latin typeface="Play"/>
                         </a:rPr>
-                        <a:t>Reference item 027</a:t>
+                        <a:t>Запись справочника 027</a:t>
                       </a:r>
                     </a:p>
                   </a:txBody>
@@ -12272,7 +12384,7 @@
                         <a:rPr sz="1600">
                           <a:latin typeface="Play"/>
                         </a:rPr>
-                        <a:t>Reference item 028</a:t>
+                        <a:t>Запись справочника 028</a:t>
                       </a:r>
                     </a:p>
                   </a:txBody>
@@ -12427,7 +12539,7 @@
                 </a:solidFill>
                 <a:latin typeface="Play"/>
               </a:rPr>
-              <a:t>Источник: reference_201.csv · 201 исходных строк</a:t>
+              <a:t>Источник: reference_201.csv</a:t>
             </a:r>
           </a:p>
           <a:p>
@@ -12438,7 +12550,7 @@
                 </a:solidFill>
                 <a:latin typeface="Play"/>
               </a:rPr>
-              <a:t>Охват: страница 4/29; строки источника 23–29 из 201; пропуски показаны как в источнике.</a:t>
+              <a:t>Охват: 201 из 201 строк; исключено: 0. Страница 4/29. Показано: 7.</a:t>
             </a:r>
           </a:p>
         </p:txBody>
@@ -12540,7 +12652,7 @@
                           </a:solidFill>
                           <a:latin typeface="Play"/>
                         </a:rPr>
-                        <a:t>reference_id</a:t>
+                        <a:t>Код записи</a:t>
                       </a:r>
                     </a:p>
                   </a:txBody>
@@ -12562,7 +12674,7 @@
                           </a:solidFill>
                           <a:latin typeface="Play"/>
                         </a:rPr>
-                        <a:t>label</a:t>
+                        <a:t>Наименование</a:t>
                       </a:r>
                     </a:p>
                   </a:txBody>
@@ -12602,7 +12714,7 @@
                         <a:rPr sz="1600">
                           <a:latin typeface="Play"/>
                         </a:rPr>
-                        <a:t>Reference item 029</a:t>
+                        <a:t>Запись справочника 029</a:t>
                       </a:r>
                     </a:p>
                   </a:txBody>
@@ -12640,7 +12752,7 @@
                         <a:rPr sz="1600">
                           <a:latin typeface="Play"/>
                         </a:rPr>
-                        <a:t>Reference item 030</a:t>
+                        <a:t>Запись справочника 030</a:t>
                       </a:r>
                     </a:p>
                   </a:txBody>
@@ -12678,7 +12790,7 @@
                         <a:rPr sz="1600">
                           <a:latin typeface="Play"/>
                         </a:rPr>
-                        <a:t>Reference item 031</a:t>
+                        <a:t>Запись справочника 031</a:t>
                       </a:r>
                     </a:p>
                   </a:txBody>
@@ -12716,7 +12828,7 @@
                         <a:rPr sz="1600">
                           <a:latin typeface="Play"/>
                         </a:rPr>
-                        <a:t>Reference item 032</a:t>
+                        <a:t>Запись справочника 032</a:t>
                       </a:r>
                     </a:p>
                   </a:txBody>
@@ -12754,7 +12866,7 @@
                         <a:rPr sz="1600">
                           <a:latin typeface="Play"/>
                         </a:rPr>
-                        <a:t>Reference item 033</a:t>
+                        <a:t>Запись справочника 033</a:t>
                       </a:r>
                     </a:p>
                   </a:txBody>
@@ -12792,7 +12904,7 @@
                         <a:rPr sz="1600">
                           <a:latin typeface="Play"/>
                         </a:rPr>
-                        <a:t>Reference item 034</a:t>
+                        <a:t>Запись справочника 034</a:t>
                       </a:r>
                     </a:p>
                   </a:txBody>
@@ -12830,7 +12942,7 @@
                         <a:rPr sz="1600">
                           <a:latin typeface="Play"/>
                         </a:rPr>
-                        <a:t>Reference item 035</a:t>
+                        <a:t>Запись справочника 035</a:t>
                       </a:r>
                     </a:p>
                   </a:txBody>
@@ -12985,7 +13097,7 @@
                 </a:solidFill>
                 <a:latin typeface="Play"/>
               </a:rPr>
-              <a:t>Источник: reference_201.csv · 201 исходных строк</a:t>
+              <a:t>Источник: reference_201.csv</a:t>
             </a:r>
           </a:p>
           <a:p>
@@ -12996,7 +13108,7 @@
                 </a:solidFill>
                 <a:latin typeface="Play"/>
               </a:rPr>
-              <a:t>Охват: страница 5/29; строки источника 30–36 из 201; пропуски показаны как в источнике.</a:t>
+              <a:t>Охват: 201 из 201 строк; исключено: 0. Страница 5/29. Показано: 7.</a:t>
             </a:r>
           </a:p>
         </p:txBody>
@@ -13098,7 +13210,7 @@
                           </a:solidFill>
                           <a:latin typeface="Play"/>
                         </a:rPr>
-                        <a:t>reference_id</a:t>
+                        <a:t>Код записи</a:t>
                       </a:r>
                     </a:p>
                   </a:txBody>
@@ -13120,7 +13232,7 @@
                           </a:solidFill>
                           <a:latin typeface="Play"/>
                         </a:rPr>
-                        <a:t>label</a:t>
+                        <a:t>Наименование</a:t>
                       </a:r>
                     </a:p>
                   </a:txBody>
@@ -13160,7 +13272,7 @@
                         <a:rPr sz="1600">
                           <a:latin typeface="Play"/>
                         </a:rPr>
-                        <a:t>Reference item 036</a:t>
+                        <a:t>Запись справочника 036</a:t>
                       </a:r>
                     </a:p>
                   </a:txBody>
@@ -13198,7 +13310,7 @@
                         <a:rPr sz="1600">
                           <a:latin typeface="Play"/>
                         </a:rPr>
-                        <a:t>Reference item 037</a:t>
+                        <a:t>Запись справочника 037</a:t>
                       </a:r>
                     </a:p>
                   </a:txBody>
@@ -13236,7 +13348,7 @@
                         <a:rPr sz="1600">
                           <a:latin typeface="Play"/>
                         </a:rPr>
-                        <a:t>Reference item 038</a:t>
+                        <a:t>Запись справочника 038</a:t>
                       </a:r>
                     </a:p>
                   </a:txBody>
@@ -13274,7 +13386,7 @@
                         <a:rPr sz="1600">
                           <a:latin typeface="Play"/>
                         </a:rPr>
-                        <a:t>Reference item 039</a:t>
+                        <a:t>Запись справочника 039</a:t>
                       </a:r>
                     </a:p>
                   </a:txBody>
@@ -13312,7 +13424,7 @@
                         <a:rPr sz="1600">
                           <a:latin typeface="Play"/>
                         </a:rPr>
-                        <a:t>Reference item 040</a:t>
+                        <a:t>Запись справочника 040</a:t>
                       </a:r>
                     </a:p>
                   </a:txBody>
@@ -13350,7 +13462,7 @@
                         <a:rPr sz="1600">
                           <a:latin typeface="Play"/>
                         </a:rPr>
-                        <a:t>Reference item 041</a:t>
+                        <a:t>Запись справочника 041</a:t>
                       </a:r>
                     </a:p>
                   </a:txBody>
@@ -13388,7 +13500,7 @@
                         <a:rPr sz="1600">
                           <a:latin typeface="Play"/>
                         </a:rPr>
-                        <a:t>Reference item 042</a:t>
+                        <a:t>Запись справочника 042</a:t>
                       </a:r>
                     </a:p>
                   </a:txBody>
@@ -13543,7 +13655,7 @@
                 </a:solidFill>
                 <a:latin typeface="Play"/>
               </a:rPr>
-              <a:t>Источник: reference_201.csv · 201 исходных строк</a:t>
+              <a:t>Источник: reference_201.csv</a:t>
             </a:r>
           </a:p>
           <a:p>
@@ -13554,7 +13666,7 @@
                 </a:solidFill>
                 <a:latin typeface="Play"/>
               </a:rPr>
-              <a:t>Охват: страница 6/29; строки источника 37–43 из 201; пропуски показаны как в источнике.</a:t>
+              <a:t>Охват: 201 из 201 строк; исключено: 0. Страница 6/29. Показано: 7.</a:t>
             </a:r>
           </a:p>
         </p:txBody>
@@ -13656,7 +13768,7 @@
                           </a:solidFill>
                           <a:latin typeface="Play"/>
                         </a:rPr>
-                        <a:t>reference_id</a:t>
+                        <a:t>Код записи</a:t>
                       </a:r>
                     </a:p>
                   </a:txBody>
@@ -13678,7 +13790,7 @@
                           </a:solidFill>
                           <a:latin typeface="Play"/>
                         </a:rPr>
-                        <a:t>label</a:t>
+                        <a:t>Наименование</a:t>
                       </a:r>
                     </a:p>
                   </a:txBody>
@@ -13718,7 +13830,7 @@
                         <a:rPr sz="1600">
                           <a:latin typeface="Play"/>
                         </a:rPr>
-                        <a:t>Reference item 043</a:t>
+                        <a:t>Запись справочника 043</a:t>
                       </a:r>
                     </a:p>
                   </a:txBody>
@@ -13756,7 +13868,7 @@
                         <a:rPr sz="1600">
                           <a:latin typeface="Play"/>
                         </a:rPr>
-                        <a:t>Reference item 044</a:t>
+                        <a:t>Запись справочника 044</a:t>
                       </a:r>
                     </a:p>
                   </a:txBody>
@@ -13794,7 +13906,7 @@
                         <a:rPr sz="1600">
                           <a:latin typeface="Play"/>
                         </a:rPr>
-                        <a:t>Reference item 045</a:t>
+                        <a:t>Запись справочника 045</a:t>
                       </a:r>
                     </a:p>
                   </a:txBody>
@@ -13832,7 +13944,7 @@
                         <a:rPr sz="1600">
                           <a:latin typeface="Play"/>
                         </a:rPr>
-                        <a:t>Reference item 046</a:t>
+                        <a:t>Запись справочника 046</a:t>
                       </a:r>
                     </a:p>
                   </a:txBody>
@@ -13870,7 +13982,7 @@
                         <a:rPr sz="1600">
                           <a:latin typeface="Play"/>
                         </a:rPr>
-                        <a:t>Reference item 047</a:t>
+                        <a:t>Запись справочника 047</a:t>
                       </a:r>
                     </a:p>
                   </a:txBody>
@@ -13908,7 +14020,7 @@
                         <a:rPr sz="1600">
                           <a:latin typeface="Play"/>
                         </a:rPr>
-                        <a:t>Reference item 048</a:t>
+                        <a:t>Запись справочника 048</a:t>
                       </a:r>
                     </a:p>
                   </a:txBody>
@@ -13946,7 +14058,7 @@
                         <a:rPr sz="1600">
                           <a:latin typeface="Play"/>
                         </a:rPr>
-                        <a:t>Reference item 049</a:t>
+                        <a:t>Запись справочника 049</a:t>
                       </a:r>
                     </a:p>
                   </a:txBody>
@@ -14101,7 +14213,7 @@
                 </a:solidFill>
                 <a:latin typeface="Play"/>
               </a:rPr>
-              <a:t>Источник: reference_201.csv · 201 исходных строк</a:t>
+              <a:t>Источник: reference_201.csv</a:t>
             </a:r>
           </a:p>
           <a:p>
@@ -14112,7 +14224,7 @@
                 </a:solidFill>
                 <a:latin typeface="Play"/>
               </a:rPr>
-              <a:t>Охват: страница 7/29; строки источника 44–50 из 201; пропуски показаны как в источнике.</a:t>
+              <a:t>Охват: 201 из 201 строк; исключено: 0. Страница 7/29. Показано: 7.</a:t>
             </a:r>
           </a:p>
         </p:txBody>
@@ -14214,7 +14326,7 @@
                           </a:solidFill>
                           <a:latin typeface="Play"/>
                         </a:rPr>
-                        <a:t>reference_id</a:t>
+                        <a:t>Код записи</a:t>
                       </a:r>
                     </a:p>
                   </a:txBody>
@@ -14236,7 +14348,7 @@
                           </a:solidFill>
                           <a:latin typeface="Play"/>
                         </a:rPr>
-                        <a:t>label</a:t>
+                        <a:t>Наименование</a:t>
                       </a:r>
                     </a:p>
                   </a:txBody>
@@ -14276,7 +14388,7 @@
                         <a:rPr sz="1600">
                           <a:latin typeface="Play"/>
                         </a:rPr>
-                        <a:t>Reference item 050</a:t>
+                        <a:t>Запись справочника 050</a:t>
                       </a:r>
                     </a:p>
                   </a:txBody>
@@ -14314,7 +14426,7 @@
                         <a:rPr sz="1600">
                           <a:latin typeface="Play"/>
                         </a:rPr>
-                        <a:t>Reference item 051</a:t>
+                        <a:t>Запись справочника 051</a:t>
                       </a:r>
                     </a:p>
                   </a:txBody>
@@ -14352,7 +14464,7 @@
                         <a:rPr sz="1600">
                           <a:latin typeface="Play"/>
                         </a:rPr>
-                        <a:t>Reference item 052</a:t>
+                        <a:t>Запись справочника 052</a:t>
                       </a:r>
                     </a:p>
                   </a:txBody>
@@ -14390,7 +14502,7 @@
                         <a:rPr sz="1600">
                           <a:latin typeface="Play"/>
                         </a:rPr>
-                        <a:t>Reference item 053</a:t>
+                        <a:t>Запись справочника 053</a:t>
                       </a:r>
                     </a:p>
                   </a:txBody>
@@ -14428,7 +14540,7 @@
                         <a:rPr sz="1600">
                           <a:latin typeface="Play"/>
                         </a:rPr>
-                        <a:t>Reference item 054</a:t>
+                        <a:t>Запись справочника 054</a:t>
                       </a:r>
                     </a:p>
                   </a:txBody>
@@ -14466,7 +14578,7 @@
                         <a:rPr sz="1600">
                           <a:latin typeface="Play"/>
                         </a:rPr>
-                        <a:t>Reference item 055</a:t>
+                        <a:t>Запись справочника 055</a:t>
                       </a:r>
                     </a:p>
                   </a:txBody>
@@ -14504,7 +14616,7 @@
                         <a:rPr sz="1600">
                           <a:latin typeface="Play"/>
                         </a:rPr>
-                        <a:t>Reference item 056</a:t>
+                        <a:t>Запись справочника 056</a:t>
                       </a:r>
                     </a:p>
                   </a:txBody>
@@ -14659,7 +14771,7 @@
                 </a:solidFill>
                 <a:latin typeface="Play"/>
               </a:rPr>
-              <a:t>Источник: reference_201.csv · 201 исходных строк</a:t>
+              <a:t>Источник: reference_201.csv</a:t>
             </a:r>
           </a:p>
           <a:p>
@@ -14670,7 +14782,7 @@
                 </a:solidFill>
                 <a:latin typeface="Play"/>
               </a:rPr>
-              <a:t>Охват: страница 8/29; строки источника 51–57 из 201; пропуски показаны как в источнике.</a:t>
+              <a:t>Охват: 201 из 201 строк; исключено: 0. Страница 8/29. Показано: 7.</a:t>
             </a:r>
           </a:p>
         </p:txBody>
@@ -14772,7 +14884,7 @@
                           </a:solidFill>
                           <a:latin typeface="Play"/>
                         </a:rPr>
-                        <a:t>reference_id</a:t>
+                        <a:t>Код записи</a:t>
                       </a:r>
                     </a:p>
                   </a:txBody>
@@ -14794,7 +14906,7 @@
                           </a:solidFill>
                           <a:latin typeface="Play"/>
                         </a:rPr>
-                        <a:t>label</a:t>
+                        <a:t>Наименование</a:t>
                       </a:r>
                     </a:p>
                   </a:txBody>
@@ -14834,7 +14946,7 @@
                         <a:rPr sz="1600">
                           <a:latin typeface="Play"/>
                         </a:rPr>
-                        <a:t>Reference item 057</a:t>
+                        <a:t>Запись справочника 057</a:t>
                       </a:r>
                     </a:p>
                   </a:txBody>
@@ -14872,7 +14984,7 @@
                         <a:rPr sz="1600">
                           <a:latin typeface="Play"/>
                         </a:rPr>
-                        <a:t>Reference item 058</a:t>
+                        <a:t>Запись справочника 058</a:t>
                       </a:r>
                     </a:p>
                   </a:txBody>
@@ -14910,7 +15022,7 @@
                         <a:rPr sz="1600">
                           <a:latin typeface="Play"/>
                         </a:rPr>
-                        <a:t>Reference item 059</a:t>
+                        <a:t>Запись справочника 059</a:t>
                       </a:r>
                     </a:p>
                   </a:txBody>
@@ -14948,7 +15060,7 @@
                         <a:rPr sz="1600">
                           <a:latin typeface="Play"/>
                         </a:rPr>
-                        <a:t>Reference item 060</a:t>
+                        <a:t>Запись справочника 060</a:t>
                       </a:r>
                     </a:p>
                   </a:txBody>
@@ -14986,7 +15098,7 @@
                         <a:rPr sz="1600">
                           <a:latin typeface="Play"/>
                         </a:rPr>
-                        <a:t>Reference item 061</a:t>
+                        <a:t>Запись справочника 061</a:t>
                       </a:r>
                     </a:p>
                   </a:txBody>
@@ -15024,7 +15136,7 @@
                         <a:rPr sz="1600">
                           <a:latin typeface="Play"/>
                         </a:rPr>
-                        <a:t>Reference item 062</a:t>
+                        <a:t>Запись справочника 062</a:t>
                       </a:r>
                     </a:p>
                   </a:txBody>
@@ -15062,7 +15174,7 @@
                         <a:rPr sz="1600">
                           <a:latin typeface="Play"/>
                         </a:rPr>
-                        <a:t>Reference item 063</a:t>
+                        <a:t>Запись справочника 063</a:t>
                       </a:r>
                     </a:p>
                   </a:txBody>
@@ -15217,7 +15329,7 @@
                 </a:solidFill>
                 <a:latin typeface="Play"/>
               </a:rPr>
-              <a:t>Источник: reference_201.csv · 201 исходных строк</a:t>
+              <a:t>Источник: reference_201.csv</a:t>
             </a:r>
           </a:p>
           <a:p>
@@ -15228,7 +15340,7 @@
                 </a:solidFill>
                 <a:latin typeface="Play"/>
               </a:rPr>
-              <a:t>Охват: страница 9/29; строки источника 58–64 из 201; пропуски показаны как в источнике.</a:t>
+              <a:t>Охват: 201 из 201 строк; исключено: 0. Страница 9/29. Показано: 7.</a:t>
             </a:r>
           </a:p>
         </p:txBody>
@@ -15330,7 +15442,7 @@
                           </a:solidFill>
                           <a:latin typeface="Play"/>
                         </a:rPr>
-                        <a:t>reference_id</a:t>
+                        <a:t>Код записи</a:t>
                       </a:r>
                     </a:p>
                   </a:txBody>
@@ -15352,7 +15464,7 @@
                           </a:solidFill>
                           <a:latin typeface="Play"/>
                         </a:rPr>
-                        <a:t>label</a:t>
+                        <a:t>Наименование</a:t>
                       </a:r>
                     </a:p>
                   </a:txBody>
@@ -15392,7 +15504,7 @@
                         <a:rPr sz="1600">
                           <a:latin typeface="Play"/>
                         </a:rPr>
-                        <a:t>Reference item 064</a:t>
+                        <a:t>Запись справочника 064</a:t>
                       </a:r>
                     </a:p>
                   </a:txBody>
@@ -15430,7 +15542,7 @@
                         <a:rPr sz="1600">
                           <a:latin typeface="Play"/>
                         </a:rPr>
-                        <a:t>Reference item 065</a:t>
+                        <a:t>Запись справочника 065</a:t>
                       </a:r>
                     </a:p>
                   </a:txBody>
@@ -15468,7 +15580,7 @@
                         <a:rPr sz="1600">
                           <a:latin typeface="Play"/>
                         </a:rPr>
-                        <a:t>Reference item 066</a:t>
+                        <a:t>Запись справочника 066</a:t>
                       </a:r>
                     </a:p>
                   </a:txBody>
@@ -15506,7 +15618,7 @@
                         <a:rPr sz="1600">
                           <a:latin typeface="Play"/>
                         </a:rPr>
-                        <a:t>Reference item 067</a:t>
+                        <a:t>Запись справочника 067</a:t>
                       </a:r>
                     </a:p>
                   </a:txBody>
@@ -15544,7 +15656,7 @@
                         <a:rPr sz="1600">
                           <a:latin typeface="Play"/>
                         </a:rPr>
-                        <a:t>Reference item 068</a:t>
+                        <a:t>Запись справочника 068</a:t>
                       </a:r>
                     </a:p>
                   </a:txBody>
@@ -15582,7 +15694,7 @@
                         <a:rPr sz="1600">
                           <a:latin typeface="Play"/>
                         </a:rPr>
-                        <a:t>Reference item 069</a:t>
+                        <a:t>Запись справочника 069</a:t>
                       </a:r>
                     </a:p>
                   </a:txBody>
@@ -15620,7 +15732,7 @@
                         <a:rPr sz="1600">
                           <a:latin typeface="Play"/>
                         </a:rPr>
-                        <a:t>Reference item 070</a:t>
+                        <a:t>Запись справочника 070</a:t>
                       </a:r>
                     </a:p>
                   </a:txBody>
@@ -15775,7 +15887,7 @@
                 </a:solidFill>
                 <a:latin typeface="Play"/>
               </a:rPr>
-              <a:t>Источник: reference_201.csv · 201 исходных строк</a:t>
+              <a:t>Источник: reference_201.csv</a:t>
             </a:r>
           </a:p>
           <a:p>
@@ -15786,7 +15898,7 @@
                 </a:solidFill>
                 <a:latin typeface="Play"/>
               </a:rPr>
-              <a:t>Охват: страница 10/29; строки источника 65–71 из 201; пропуски показаны как в источнике.</a:t>
+              <a:t>Охват: 201 из 201 строк; исключено: 0. Страница 10/29. Показано: 7.</a:t>
             </a:r>
           </a:p>
         </p:txBody>
@@ -15888,7 +16000,7 @@
                           </a:solidFill>
                           <a:latin typeface="Play"/>
                         </a:rPr>
-                        <a:t>reference_id</a:t>
+                        <a:t>Код записи</a:t>
                       </a:r>
                     </a:p>
                   </a:txBody>
@@ -15910,7 +16022,7 @@
                           </a:solidFill>
                           <a:latin typeface="Play"/>
                         </a:rPr>
-                        <a:t>label</a:t>
+                        <a:t>Наименование</a:t>
                       </a:r>
                     </a:p>
                   </a:txBody>
@@ -15950,7 +16062,7 @@
                         <a:rPr sz="1600">
                           <a:latin typeface="Play"/>
                         </a:rPr>
-                        <a:t>Reference item 071</a:t>
+                        <a:t>Запись справочника 071</a:t>
                       </a:r>
                     </a:p>
                   </a:txBody>
@@ -15988,7 +16100,7 @@
                         <a:rPr sz="1600">
                           <a:latin typeface="Play"/>
                         </a:rPr>
-                        <a:t>Reference item 072</a:t>
+                        <a:t>Запись справочника 072</a:t>
                       </a:r>
                     </a:p>
                   </a:txBody>
@@ -16026,7 +16138,7 @@
                         <a:rPr sz="1600">
                           <a:latin typeface="Play"/>
                         </a:rPr>
-                        <a:t>Reference item 073</a:t>
+                        <a:t>Запись справочника 073</a:t>
                       </a:r>
                     </a:p>
                   </a:txBody>
@@ -16064,7 +16176,7 @@
                         <a:rPr sz="1600">
                           <a:latin typeface="Play"/>
                         </a:rPr>
-                        <a:t>Reference item 074</a:t>
+                        <a:t>Запись справочника 074</a:t>
                       </a:r>
                     </a:p>
                   </a:txBody>
@@ -16102,7 +16214,7 @@
                         <a:rPr sz="1600">
                           <a:latin typeface="Play"/>
                         </a:rPr>
-                        <a:t>Reference item 075</a:t>
+                        <a:t>Запись справочника 075</a:t>
                       </a:r>
                     </a:p>
                   </a:txBody>
@@ -16140,7 +16252,7 @@
                         <a:rPr sz="1600">
                           <a:latin typeface="Play"/>
                         </a:rPr>
-                        <a:t>Reference item 076</a:t>
+                        <a:t>Запись справочника 076</a:t>
                       </a:r>
                     </a:p>
                   </a:txBody>
@@ -16178,7 +16290,7 @@
                         <a:rPr sz="1600">
                           <a:latin typeface="Play"/>
                         </a:rPr>
-                        <a:t>Reference item 077</a:t>
+                        <a:t>Запись справочника 077</a:t>
                       </a:r>
                     </a:p>
                   </a:txBody>
@@ -16333,7 +16445,7 @@
                 </a:solidFill>
                 <a:latin typeface="Play"/>
               </a:rPr>
-              <a:t>Источник: reference_201.csv · 201 исходных строк</a:t>
+              <a:t>Источник: reference_201.csv</a:t>
             </a:r>
           </a:p>
           <a:p>
@@ -16344,7 +16456,7 @@
                 </a:solidFill>
                 <a:latin typeface="Play"/>
               </a:rPr>
-              <a:t>Охват: страница 11/29; строки источника 72–78 из 201; пропуски показаны как в источнике.</a:t>
+              <a:t>Охват: 201 из 201 строк; исключено: 0. Страница 11/29. Показано: 7.</a:t>
             </a:r>
           </a:p>
         </p:txBody>
@@ -16446,7 +16558,7 @@
                           </a:solidFill>
                           <a:latin typeface="Play"/>
                         </a:rPr>
-                        <a:t>reference_id</a:t>
+                        <a:t>Код записи</a:t>
                       </a:r>
                     </a:p>
                   </a:txBody>
@@ -16468,7 +16580,7 @@
                           </a:solidFill>
                           <a:latin typeface="Play"/>
                         </a:rPr>
-                        <a:t>label</a:t>
+                        <a:t>Наименование</a:t>
                       </a:r>
                     </a:p>
                   </a:txBody>
@@ -16508,7 +16620,7 @@
                         <a:rPr sz="1600">
                           <a:latin typeface="Play"/>
                         </a:rPr>
-                        <a:t>Reference item 078</a:t>
+                        <a:t>Запись справочника 078</a:t>
                       </a:r>
                     </a:p>
                   </a:txBody>
@@ -16546,7 +16658,7 @@
                         <a:rPr sz="1600">
                           <a:latin typeface="Play"/>
                         </a:rPr>
-                        <a:t>Reference item 079</a:t>
+                        <a:t>Запись справочника 079</a:t>
                       </a:r>
                     </a:p>
                   </a:txBody>
@@ -16584,7 +16696,7 @@
                         <a:rPr sz="1600">
                           <a:latin typeface="Play"/>
                         </a:rPr>
-                        <a:t>Reference item 080</a:t>
+                        <a:t>Запись справочника 080</a:t>
                       </a:r>
                     </a:p>
                   </a:txBody>
@@ -16622,7 +16734,7 @@
                         <a:rPr sz="1600">
                           <a:latin typeface="Play"/>
                         </a:rPr>
-                        <a:t>Reference item 081</a:t>
+                        <a:t>Запись справочника 081</a:t>
                       </a:r>
                     </a:p>
                   </a:txBody>
@@ -16660,7 +16772,7 @@
                         <a:rPr sz="1600">
                           <a:latin typeface="Play"/>
                         </a:rPr>
-                        <a:t>Reference item 082</a:t>
+                        <a:t>Запись справочника 082</a:t>
                       </a:r>
                     </a:p>
                   </a:txBody>
@@ -16698,7 +16810,7 @@
                         <a:rPr sz="1600">
                           <a:latin typeface="Play"/>
                         </a:rPr>
-                        <a:t>Reference item 083</a:t>
+                        <a:t>Запись справочника 083</a:t>
                       </a:r>
                     </a:p>
                   </a:txBody>
@@ -16736,7 +16848,7 @@
                         <a:rPr sz="1600">
                           <a:latin typeface="Play"/>
                         </a:rPr>
-                        <a:t>Reference item 084</a:t>
+                        <a:t>Запись справочника 084</a:t>
                       </a:r>
                     </a:p>
                   </a:txBody>
@@ -16891,7 +17003,7 @@
                 </a:solidFill>
                 <a:latin typeface="Play"/>
               </a:rPr>
-              <a:t>Источник: reference_201.csv · 201 исходных строк</a:t>
+              <a:t>Источник: reference_201.csv</a:t>
             </a:r>
           </a:p>
           <a:p>
@@ -16902,7 +17014,7 @@
                 </a:solidFill>
                 <a:latin typeface="Play"/>
               </a:rPr>
-              <a:t>Охват: страница 12/29; строки источника 79–85 из 201; пропуски показаны как в источнике.</a:t>
+              <a:t>Охват: 201 из 201 строк; исключено: 0. Страница 12/29. Показано: 7.</a:t>
             </a:r>
           </a:p>
         </p:txBody>
@@ -17004,7 +17116,7 @@
                           </a:solidFill>
                           <a:latin typeface="Play"/>
                         </a:rPr>
-                        <a:t>reference_id</a:t>
+                        <a:t>Код записи</a:t>
                       </a:r>
                     </a:p>
                   </a:txBody>
@@ -17026,7 +17138,7 @@
                           </a:solidFill>
                           <a:latin typeface="Play"/>
                         </a:rPr>
-                        <a:t>label</a:t>
+                        <a:t>Наименование</a:t>
                       </a:r>
                     </a:p>
                   </a:txBody>
@@ -17066,7 +17178,7 @@
                         <a:rPr sz="1600">
                           <a:latin typeface="Play"/>
                         </a:rPr>
-                        <a:t>Reference item 085</a:t>
+                        <a:t>Запись справочника 085</a:t>
                       </a:r>
                     </a:p>
                   </a:txBody>
@@ -17104,7 +17216,7 @@
                         <a:rPr sz="1600">
                           <a:latin typeface="Play"/>
                         </a:rPr>
-                        <a:t>Reference item 086</a:t>
+                        <a:t>Запись справочника 086</a:t>
                       </a:r>
                     </a:p>
                   </a:txBody>
@@ -17142,7 +17254,7 @@
                         <a:rPr sz="1600">
                           <a:latin typeface="Play"/>
                         </a:rPr>
-                        <a:t>Reference item 087</a:t>
+                        <a:t>Запись справочника 087</a:t>
                       </a:r>
                     </a:p>
                   </a:txBody>
@@ -17180,7 +17292,7 @@
                         <a:rPr sz="1600">
                           <a:latin typeface="Play"/>
                         </a:rPr>
-                        <a:t>Reference item 088</a:t>
+                        <a:t>Запись справочника 088</a:t>
                       </a:r>
                     </a:p>
                   </a:txBody>
@@ -17218,7 +17330,7 @@
                         <a:rPr sz="1600">
                           <a:latin typeface="Play"/>
                         </a:rPr>
-                        <a:t>Reference item 089</a:t>
+                        <a:t>Запись справочника 089</a:t>
                       </a:r>
                     </a:p>
                   </a:txBody>
@@ -17256,7 +17368,7 @@
                         <a:rPr sz="1600">
                           <a:latin typeface="Play"/>
                         </a:rPr>
-                        <a:t>Reference item 090</a:t>
+                        <a:t>Запись справочника 090</a:t>
                       </a:r>
                     </a:p>
                   </a:txBody>
@@ -17294,7 +17406,7 @@
                         <a:rPr sz="1600">
                           <a:latin typeface="Play"/>
                         </a:rPr>
-                        <a:t>Reference item 091</a:t>
+                        <a:t>Запись справочника 091</a:t>
                       </a:r>
                     </a:p>
                   </a:txBody>
@@ -17449,7 +17561,7 @@
                 </a:solidFill>
                 <a:latin typeface="Play"/>
               </a:rPr>
-              <a:t>Источник: reference_201.csv · 201 исходных строк</a:t>
+              <a:t>Источник: reference_201.csv</a:t>
             </a:r>
           </a:p>
           <a:p>
@@ -17460,7 +17572,7 @@
                 </a:solidFill>
                 <a:latin typeface="Play"/>
               </a:rPr>
-              <a:t>Охват: страница 13/29; строки источника 86–92 из 201; пропуски показаны как в источнике.</a:t>
+              <a:t>Охват: 201 из 201 строк; исключено: 0. Страница 13/29. Показано: 7.</a:t>
             </a:r>
           </a:p>
         </p:txBody>
@@ -17562,7 +17674,7 @@
                           </a:solidFill>
                           <a:latin typeface="Play"/>
                         </a:rPr>
-                        <a:t>reference_id</a:t>
+                        <a:t>Код записи</a:t>
                       </a:r>
                     </a:p>
                   </a:txBody>
@@ -17584,7 +17696,7 @@
                           </a:solidFill>
                           <a:latin typeface="Play"/>
                         </a:rPr>
-                        <a:t>label</a:t>
+                        <a:t>Наименование</a:t>
                       </a:r>
                     </a:p>
                   </a:txBody>
@@ -17624,7 +17736,7 @@
                         <a:rPr sz="1600">
                           <a:latin typeface="Play"/>
                         </a:rPr>
-                        <a:t>Reference item 092</a:t>
+                        <a:t>Запись справочника 092</a:t>
                       </a:r>
                     </a:p>
                   </a:txBody>
@@ -17662,7 +17774,7 @@
                         <a:rPr sz="1600">
                           <a:latin typeface="Play"/>
                         </a:rPr>
-                        <a:t>Reference item 093</a:t>
+                        <a:t>Запись справочника 093</a:t>
                       </a:r>
                     </a:p>
                   </a:txBody>
@@ -17700,7 +17812,7 @@
                         <a:rPr sz="1600">
                           <a:latin typeface="Play"/>
                         </a:rPr>
-                        <a:t>Reference item 094</a:t>
+                        <a:t>Запись справочника 094</a:t>
                       </a:r>
                     </a:p>
                   </a:txBody>
@@ -17738,7 +17850,7 @@
                         <a:rPr sz="1600">
                           <a:latin typeface="Play"/>
                         </a:rPr>
-                        <a:t>Reference item 095</a:t>
+                        <a:t>Запись справочника 095</a:t>
                       </a:r>
                     </a:p>
                   </a:txBody>
@@ -17776,7 +17888,7 @@
                         <a:rPr sz="1600">
                           <a:latin typeface="Play"/>
                         </a:rPr>
-                        <a:t>Reference item 096</a:t>
+                        <a:t>Запись справочника 096</a:t>
                       </a:r>
                     </a:p>
                   </a:txBody>
@@ -17814,7 +17926,7 @@
                         <a:rPr sz="1600">
                           <a:latin typeface="Play"/>
                         </a:rPr>
-                        <a:t>Reference item 097</a:t>
+                        <a:t>Запись справочника 097</a:t>
                       </a:r>
                     </a:p>
                   </a:txBody>
@@ -17852,7 +17964,7 @@
                         <a:rPr sz="1600">
                           <a:latin typeface="Play"/>
                         </a:rPr>
-                        <a:t>Reference item 098</a:t>
+                        <a:t>Запись справочника 098</a:t>
                       </a:r>
                     </a:p>
                   </a:txBody>
@@ -18007,7 +18119,7 @@
                 </a:solidFill>
                 <a:latin typeface="Play"/>
               </a:rPr>
-              <a:t>Источник: reference_201.csv · 201 исходных строк</a:t>
+              <a:t>Источник: reference_201.csv</a:t>
             </a:r>
           </a:p>
           <a:p>
@@ -18018,7 +18130,7 @@
                 </a:solidFill>
                 <a:latin typeface="Play"/>
               </a:rPr>
-              <a:t>Охват: страница 14/29; строки источника 93–99 из 201; пропуски показаны как в источнике.</a:t>
+              <a:t>Охват: 201 из 201 строк; исключено: 0. Страница 14/29. Показано: 7.</a:t>
             </a:r>
           </a:p>
         </p:txBody>
@@ -18120,7 +18232,7 @@
                           </a:solidFill>
                           <a:latin typeface="Play"/>
                         </a:rPr>
-                        <a:t>reference_id</a:t>
+                        <a:t>Код записи</a:t>
                       </a:r>
                     </a:p>
                   </a:txBody>
@@ -18142,7 +18254,7 @@
                           </a:solidFill>
                           <a:latin typeface="Play"/>
                         </a:rPr>
-                        <a:t>label</a:t>
+                        <a:t>Наименование</a:t>
                       </a:r>
                     </a:p>
                   </a:txBody>
@@ -18182,7 +18294,7 @@
                         <a:rPr sz="1600">
                           <a:latin typeface="Play"/>
                         </a:rPr>
-                        <a:t>Reference item 099</a:t>
+                        <a:t>Запись справочника 099</a:t>
                       </a:r>
                     </a:p>
                   </a:txBody>
@@ -18220,7 +18332,7 @@
                         <a:rPr sz="1600">
                           <a:latin typeface="Play"/>
                         </a:rPr>
-                        <a:t>Reference item 100</a:t>
+                        <a:t>Запись справочника 100</a:t>
                       </a:r>
                     </a:p>
                   </a:txBody>
@@ -18258,7 +18370,7 @@
                         <a:rPr sz="1600">
                           <a:latin typeface="Play"/>
                         </a:rPr>
-                        <a:t>Reference item 101</a:t>
+                        <a:t>Запись справочника 101</a:t>
                       </a:r>
                     </a:p>
                   </a:txBody>
@@ -18296,7 +18408,7 @@
                         <a:rPr sz="1600">
                           <a:latin typeface="Play"/>
                         </a:rPr>
-                        <a:t>Reference item 102</a:t>
+                        <a:t>Запись справочника 102</a:t>
                       </a:r>
                     </a:p>
                   </a:txBody>
@@ -18334,7 +18446,7 @@
                         <a:rPr sz="1600">
                           <a:latin typeface="Play"/>
                         </a:rPr>
-                        <a:t>Reference item 103</a:t>
+                        <a:t>Запись справочника 103</a:t>
                       </a:r>
                     </a:p>
                   </a:txBody>
@@ -18372,7 +18484,7 @@
                         <a:rPr sz="1600">
                           <a:latin typeface="Play"/>
                         </a:rPr>
-                        <a:t>Reference item 104</a:t>
+                        <a:t>Запись справочника 104</a:t>
                       </a:r>
                     </a:p>
                   </a:txBody>
@@ -18410,7 +18522,7 @@
                         <a:rPr sz="1600">
                           <a:latin typeface="Play"/>
                         </a:rPr>
-                        <a:t>Reference item 105</a:t>
+                        <a:t>Запись справочника 105</a:t>
                       </a:r>
                     </a:p>
                   </a:txBody>
@@ -18565,7 +18677,7 @@
                 </a:solidFill>
                 <a:latin typeface="Play"/>
               </a:rPr>
-              <a:t>Источник: reference_201.csv · 201 исходных строк</a:t>
+              <a:t>Источник: reference_201.csv</a:t>
             </a:r>
           </a:p>
           <a:p>
@@ -18576,7 +18688,7 @@
                 </a:solidFill>
                 <a:latin typeface="Play"/>
               </a:rPr>
-              <a:t>Охват: страница 15/29; строки источника 100–106 из 201; пропуски показаны как в источнике.</a:t>
+              <a:t>Охват: 201 из 201 строк; исключено: 0. Страница 15/29. Показано: 7.</a:t>
             </a:r>
           </a:p>
         </p:txBody>
@@ -18678,7 +18790,7 @@
                           </a:solidFill>
                           <a:latin typeface="Play"/>
                         </a:rPr>
-                        <a:t>reference_id</a:t>
+                        <a:t>Код записи</a:t>
                       </a:r>
                     </a:p>
                   </a:txBody>
@@ -18700,7 +18812,7 @@
                           </a:solidFill>
                           <a:latin typeface="Play"/>
                         </a:rPr>
-                        <a:t>label</a:t>
+                        <a:t>Наименование</a:t>
                       </a:r>
                     </a:p>
                   </a:txBody>
@@ -18740,7 +18852,7 @@
                         <a:rPr sz="1600">
                           <a:latin typeface="Play"/>
                         </a:rPr>
-                        <a:t>Reference item 106</a:t>
+                        <a:t>Запись справочника 106</a:t>
                       </a:r>
                     </a:p>
                   </a:txBody>
@@ -18778,7 +18890,7 @@
                         <a:rPr sz="1600">
                           <a:latin typeface="Play"/>
                         </a:rPr>
-                        <a:t>Reference item 107</a:t>
+                        <a:t>Запись справочника 107</a:t>
                       </a:r>
                     </a:p>
                   </a:txBody>
@@ -18816,7 +18928,7 @@
                         <a:rPr sz="1600">
                           <a:latin typeface="Play"/>
                         </a:rPr>
-                        <a:t>Reference item 108</a:t>
+                        <a:t>Запись справочника 108</a:t>
                       </a:r>
                     </a:p>
                   </a:txBody>
@@ -18854,7 +18966,7 @@
                         <a:rPr sz="1600">
                           <a:latin typeface="Play"/>
                         </a:rPr>
-                        <a:t>Reference item 109</a:t>
+                        <a:t>Запись справочника 109</a:t>
                       </a:r>
                     </a:p>
                   </a:txBody>
@@ -18892,7 +19004,7 @@
                         <a:rPr sz="1600">
                           <a:latin typeface="Play"/>
                         </a:rPr>
-                        <a:t>Reference item 110</a:t>
+                        <a:t>Запись справочника 110</a:t>
                       </a:r>
                     </a:p>
                   </a:txBody>
@@ -18930,7 +19042,7 @@
                         <a:rPr sz="1600">
                           <a:latin typeface="Play"/>
                         </a:rPr>
-                        <a:t>Reference item 111</a:t>
+                        <a:t>Запись справочника 111</a:t>
                       </a:r>
                     </a:p>
                   </a:txBody>
@@ -18968,7 +19080,7 @@
                         <a:rPr sz="1600">
                           <a:latin typeface="Play"/>
                         </a:rPr>
-                        <a:t>Reference item 112</a:t>
+                        <a:t>Запись справочника 112</a:t>
                       </a:r>
                     </a:p>
                   </a:txBody>
@@ -19123,7 +19235,7 @@
                 </a:solidFill>
                 <a:latin typeface="Play"/>
               </a:rPr>
-              <a:t>Источник: reference_201.csv · 201 исходных строк</a:t>
+              <a:t>Источник: reference_201.csv</a:t>
             </a:r>
           </a:p>
           <a:p>
@@ -19134,7 +19246,7 @@
                 </a:solidFill>
                 <a:latin typeface="Play"/>
               </a:rPr>
-              <a:t>Охват: страница 16/29; строки источника 107–113 из 201; пропуски показаны как в источнике.</a:t>
+              <a:t>Охват: 201 из 201 строк; исключено: 0. Страница 16/29. Показано: 7.</a:t>
             </a:r>
           </a:p>
         </p:txBody>
@@ -19236,7 +19348,7 @@
                           </a:solidFill>
                           <a:latin typeface="Play"/>
                         </a:rPr>
-                        <a:t>reference_id</a:t>
+                        <a:t>Код записи</a:t>
                       </a:r>
                     </a:p>
                   </a:txBody>
@@ -19258,7 +19370,7 @@
                           </a:solidFill>
                           <a:latin typeface="Play"/>
                         </a:rPr>
-                        <a:t>label</a:t>
+                        <a:t>Наименование</a:t>
                       </a:r>
                     </a:p>
                   </a:txBody>
@@ -19298,7 +19410,7 @@
                         <a:rPr sz="1600">
                           <a:latin typeface="Play"/>
                         </a:rPr>
-                        <a:t>Reference item 113</a:t>
+                        <a:t>Запись справочника 113</a:t>
                       </a:r>
                     </a:p>
                   </a:txBody>
@@ -19336,7 +19448,7 @@
                         <a:rPr sz="1600">
                           <a:latin typeface="Play"/>
                         </a:rPr>
-                        <a:t>Reference item 114</a:t>
+                        <a:t>Запись справочника 114</a:t>
                       </a:r>
                     </a:p>
                   </a:txBody>
@@ -19374,7 +19486,7 @@
                         <a:rPr sz="1600">
                           <a:latin typeface="Play"/>
                         </a:rPr>
-                        <a:t>Reference item 115</a:t>
+                        <a:t>Запись справочника 115</a:t>
                       </a:r>
                     </a:p>
                   </a:txBody>
@@ -19412,7 +19524,7 @@
                         <a:rPr sz="1600">
                           <a:latin typeface="Play"/>
                         </a:rPr>
-                        <a:t>Reference item 116</a:t>
+                        <a:t>Запись справочника 116</a:t>
                       </a:r>
                     </a:p>
                   </a:txBody>
@@ -19450,7 +19562,7 @@
                         <a:rPr sz="1600">
                           <a:latin typeface="Play"/>
                         </a:rPr>
-                        <a:t>Reference item 117</a:t>
+                        <a:t>Запись справочника 117</a:t>
                       </a:r>
                     </a:p>
                   </a:txBody>
@@ -19488,7 +19600,7 @@
                         <a:rPr sz="1600">
                           <a:latin typeface="Play"/>
                         </a:rPr>
-                        <a:t>Reference item 118</a:t>
+                        <a:t>Запись справочника 118</a:t>
                       </a:r>
                     </a:p>
                   </a:txBody>
@@ -19526,7 +19638,7 @@
                         <a:rPr sz="1600">
                           <a:latin typeface="Play"/>
                         </a:rPr>
-                        <a:t>Reference item 119</a:t>
+                        <a:t>Запись справочника 119</a:t>
                       </a:r>
                     </a:p>
                   </a:txBody>
@@ -19681,7 +19793,7 @@
                 </a:solidFill>
                 <a:latin typeface="Play"/>
               </a:rPr>
-              <a:t>Источник: reference_201.csv · 201 исходных строк</a:t>
+              <a:t>Источник: reference_201.csv</a:t>
             </a:r>
           </a:p>
           <a:p>
@@ -19692,7 +19804,7 @@
                 </a:solidFill>
                 <a:latin typeface="Play"/>
               </a:rPr>
-              <a:t>Охват: страница 17/29; строки источника 114–120 из 201; пропуски показаны как в источнике.</a:t>
+              <a:t>Охват: 201 из 201 строк; исключено: 0. Страница 17/29. Показано: 7.</a:t>
             </a:r>
           </a:p>
         </p:txBody>
@@ -19794,7 +19906,7 @@
                           </a:solidFill>
                           <a:latin typeface="Play"/>
                         </a:rPr>
-                        <a:t>reference_id</a:t>
+                        <a:t>Код записи</a:t>
                       </a:r>
                     </a:p>
                   </a:txBody>
@@ -19816,7 +19928,7 @@
                           </a:solidFill>
                           <a:latin typeface="Play"/>
                         </a:rPr>
-                        <a:t>label</a:t>
+                        <a:t>Наименование</a:t>
                       </a:r>
                     </a:p>
                   </a:txBody>
@@ -19856,7 +19968,7 @@
                         <a:rPr sz="1600">
                           <a:latin typeface="Play"/>
                         </a:rPr>
-                        <a:t>Reference item 120</a:t>
+                        <a:t>Запись справочника 120</a:t>
                       </a:r>
                     </a:p>
                   </a:txBody>
@@ -19894,7 +20006,7 @@
                         <a:rPr sz="1600">
                           <a:latin typeface="Play"/>
                         </a:rPr>
-                        <a:t>Reference item 121</a:t>
+                        <a:t>Запись справочника 121</a:t>
                       </a:r>
                     </a:p>
                   </a:txBody>
@@ -19932,7 +20044,7 @@
                         <a:rPr sz="1600">
                           <a:latin typeface="Play"/>
                         </a:rPr>
-                        <a:t>Reference item 122</a:t>
+                        <a:t>Запись справочника 122</a:t>
                       </a:r>
                     </a:p>
                   </a:txBody>
@@ -19970,7 +20082,7 @@
                         <a:rPr sz="1600">
                           <a:latin typeface="Play"/>
                         </a:rPr>
-                        <a:t>Reference item 123</a:t>
+                        <a:t>Запись справочника 123</a:t>
                       </a:r>
                     </a:p>
                   </a:txBody>
@@ -20008,7 +20120,7 @@
                         <a:rPr sz="1600">
                           <a:latin typeface="Play"/>
                         </a:rPr>
-                        <a:t>Reference item 124</a:t>
+                        <a:t>Запись справочника 124</a:t>
                       </a:r>
                     </a:p>
                   </a:txBody>
@@ -20046,7 +20158,7 @@
                         <a:rPr sz="1600">
                           <a:latin typeface="Play"/>
                         </a:rPr>
-                        <a:t>Reference item 125</a:t>
+                        <a:t>Запись справочника 125</a:t>
                       </a:r>
                     </a:p>
                   </a:txBody>
@@ -20084,7 +20196,7 @@
                         <a:rPr sz="1600">
                           <a:latin typeface="Play"/>
                         </a:rPr>
-                        <a:t>Reference item 126</a:t>
+                        <a:t>Запись справочника 126</a:t>
                       </a:r>
                     </a:p>
                   </a:txBody>
@@ -20239,7 +20351,7 @@
                 </a:solidFill>
                 <a:latin typeface="Play"/>
               </a:rPr>
-              <a:t>Источник: reference_201.csv · 201 исходных строк</a:t>
+              <a:t>Источник: reference_201.csv</a:t>
             </a:r>
           </a:p>
           <a:p>
@@ -20250,7 +20362,7 @@
                 </a:solidFill>
                 <a:latin typeface="Play"/>
               </a:rPr>
-              <a:t>Охват: страница 18/29; строки источника 121–127 из 201; пропуски показаны как в источнике.</a:t>
+              <a:t>Охват: 201 из 201 строк; исключено: 0. Страница 18/29. Показано: 7.</a:t>
             </a:r>
           </a:p>
         </p:txBody>
@@ -20352,7 +20464,7 @@
                           </a:solidFill>
                           <a:latin typeface="Play"/>
                         </a:rPr>
-                        <a:t>reference_id</a:t>
+                        <a:t>Код записи</a:t>
                       </a:r>
                     </a:p>
                   </a:txBody>
@@ -20374,7 +20486,7 @@
                           </a:solidFill>
                           <a:latin typeface="Play"/>
                         </a:rPr>
-                        <a:t>label</a:t>
+                        <a:t>Наименование</a:t>
                       </a:r>
                     </a:p>
                   </a:txBody>
@@ -20414,7 +20526,7 @@
                         <a:rPr sz="1600">
                           <a:latin typeface="Play"/>
                         </a:rPr>
-                        <a:t>Reference item 127</a:t>
+                        <a:t>Запись справочника 127</a:t>
                       </a:r>
                     </a:p>
                   </a:txBody>
@@ -20452,7 +20564,7 @@
                         <a:rPr sz="1600">
                           <a:latin typeface="Play"/>
                         </a:rPr>
-                        <a:t>Reference item 128</a:t>
+                        <a:t>Запись справочника 128</a:t>
                       </a:r>
                     </a:p>
                   </a:txBody>
@@ -20490,7 +20602,7 @@
                         <a:rPr sz="1600">
                           <a:latin typeface="Play"/>
                         </a:rPr>
-                        <a:t>Reference item 129</a:t>
+                        <a:t>Запись справочника 129</a:t>
                       </a:r>
                     </a:p>
                   </a:txBody>
@@ -20528,7 +20640,7 @@
                         <a:rPr sz="1600">
                           <a:latin typeface="Play"/>
                         </a:rPr>
-                        <a:t>Reference item 130</a:t>
+                        <a:t>Запись справочника 130</a:t>
                       </a:r>
                     </a:p>
                   </a:txBody>
@@ -20566,7 +20678,7 @@
                         <a:rPr sz="1600">
                           <a:latin typeface="Play"/>
                         </a:rPr>
-                        <a:t>Reference item 131</a:t>
+                        <a:t>Запись справочника 131</a:t>
                       </a:r>
                     </a:p>
                   </a:txBody>
@@ -20604,7 +20716,7 @@
                         <a:rPr sz="1600">
                           <a:latin typeface="Play"/>
                         </a:rPr>
-                        <a:t>Reference item 132</a:t>
+                        <a:t>Запись справочника 132</a:t>
                       </a:r>
                     </a:p>
                   </a:txBody>
@@ -20642,7 +20754,7 @@
                         <a:rPr sz="1600">
                           <a:latin typeface="Play"/>
                         </a:rPr>
-                        <a:t>Reference item 133</a:t>
+                        <a:t>Запись справочника 133</a:t>
                       </a:r>
                     </a:p>
                   </a:txBody>
@@ -20797,7 +20909,7 @@
                 </a:solidFill>
                 <a:latin typeface="Play"/>
               </a:rPr>
-              <a:t>Источник: reference_201.csv · 201 исходных строк</a:t>
+              <a:t>Источник: reference_201.csv</a:t>
             </a:r>
           </a:p>
           <a:p>
@@ -20808,7 +20920,7 @@
                 </a:solidFill>
                 <a:latin typeface="Play"/>
               </a:rPr>
-              <a:t>Охват: страница 19/29; строки источника 128–134 из 201; пропуски показаны как в источнике.</a:t>
+              <a:t>Охват: 201 из 201 строк; исключено: 0. Страница 19/29. Показано: 7.</a:t>
             </a:r>
           </a:p>
         </p:txBody>
@@ -20910,7 +21022,7 @@
                           </a:solidFill>
                           <a:latin typeface="Play"/>
                         </a:rPr>
-                        <a:t>reference_id</a:t>
+                        <a:t>Код записи</a:t>
                       </a:r>
                     </a:p>
                   </a:txBody>
@@ -20932,7 +21044,7 @@
                           </a:solidFill>
                           <a:latin typeface="Play"/>
                         </a:rPr>
-                        <a:t>label</a:t>
+                        <a:t>Наименование</a:t>
                       </a:r>
                     </a:p>
                   </a:txBody>
@@ -20972,7 +21084,7 @@
                         <a:rPr sz="1600">
                           <a:latin typeface="Play"/>
                         </a:rPr>
-                        <a:t>Reference item 134</a:t>
+                        <a:t>Запись справочника 134</a:t>
                       </a:r>
                     </a:p>
                   </a:txBody>
@@ -21010,7 +21122,7 @@
                         <a:rPr sz="1600">
                           <a:latin typeface="Play"/>
                         </a:rPr>
-                        <a:t>Reference item 135</a:t>
+                        <a:t>Запись справочника 135</a:t>
                       </a:r>
                     </a:p>
                   </a:txBody>
@@ -21048,7 +21160,7 @@
                         <a:rPr sz="1600">
                           <a:latin typeface="Play"/>
                         </a:rPr>
-                        <a:t>Reference item 136</a:t>
+                        <a:t>Запись справочника 136</a:t>
                       </a:r>
                     </a:p>
                   </a:txBody>
@@ -21086,7 +21198,7 @@
                         <a:rPr sz="1600">
                           <a:latin typeface="Play"/>
                         </a:rPr>
-                        <a:t>Reference item 137</a:t>
+                        <a:t>Запись справочника 137</a:t>
                       </a:r>
                     </a:p>
                   </a:txBody>
@@ -21124,7 +21236,7 @@
                         <a:rPr sz="1600">
                           <a:latin typeface="Play"/>
                         </a:rPr>
-                        <a:t>Reference item 138</a:t>
+                        <a:t>Запись справочника 138</a:t>
                       </a:r>
                     </a:p>
                   </a:txBody>
@@ -21162,7 +21274,7 @@
                         <a:rPr sz="1600">
                           <a:latin typeface="Play"/>
                         </a:rPr>
-                        <a:t>Reference item 139</a:t>
+                        <a:t>Запись справочника 139</a:t>
                       </a:r>
                     </a:p>
                   </a:txBody>
@@ -21200,7 +21312,7 @@
                         <a:rPr sz="1600">
                           <a:latin typeface="Play"/>
                         </a:rPr>
-                        <a:t>Reference item 140</a:t>
+                        <a:t>Запись справочника 140</a:t>
                       </a:r>
                     </a:p>
                   </a:txBody>
@@ -21355,7 +21467,7 @@
                 </a:solidFill>
                 <a:latin typeface="Play"/>
               </a:rPr>
-              <a:t>Источник: reference_201.csv · 201 исходных строк</a:t>
+              <a:t>Источник: reference_201.csv</a:t>
             </a:r>
           </a:p>
           <a:p>
@@ -21366,7 +21478,7 @@
                 </a:solidFill>
                 <a:latin typeface="Play"/>
               </a:rPr>
-              <a:t>Охват: страница 20/29; строки источника 135–141 из 201; пропуски показаны как в источнике.</a:t>
+              <a:t>Охват: 201 из 201 строк; исключено: 0. Страница 20/29. Показано: 7.</a:t>
             </a:r>
           </a:p>
         </p:txBody>
@@ -21468,7 +21580,7 @@
                           </a:solidFill>
                           <a:latin typeface="Play"/>
                         </a:rPr>
-                        <a:t>reference_id</a:t>
+                        <a:t>Код записи</a:t>
                       </a:r>
                     </a:p>
                   </a:txBody>
@@ -21490,7 +21602,7 @@
                           </a:solidFill>
                           <a:latin typeface="Play"/>
                         </a:rPr>
-                        <a:t>label</a:t>
+                        <a:t>Наименование</a:t>
                       </a:r>
                     </a:p>
                   </a:txBody>
@@ -21530,7 +21642,7 @@
                         <a:rPr sz="1600">
                           <a:latin typeface="Play"/>
                         </a:rPr>
-                        <a:t>Reference item 141</a:t>
+                        <a:t>Запись справочника 141</a:t>
                       </a:r>
                     </a:p>
                   </a:txBody>
@@ -21568,7 +21680,7 @@
                         <a:rPr sz="1600">
                           <a:latin typeface="Play"/>
                         </a:rPr>
-                        <a:t>Reference item 142</a:t>
+                        <a:t>Запись справочника 142</a:t>
                       </a:r>
                     </a:p>
                   </a:txBody>
@@ -21606,7 +21718,7 @@
                         <a:rPr sz="1600">
                           <a:latin typeface="Play"/>
                         </a:rPr>
-                        <a:t>Reference item 143</a:t>
+                        <a:t>Запись справочника 143</a:t>
                       </a:r>
                     </a:p>
                   </a:txBody>
@@ -21644,7 +21756,7 @@
                         <a:rPr sz="1600">
                           <a:latin typeface="Play"/>
                         </a:rPr>
-                        <a:t>Reference item 144</a:t>
+                        <a:t>Запись справочника 144</a:t>
                       </a:r>
                     </a:p>
                   </a:txBody>
@@ -21682,7 +21794,7 @@
                         <a:rPr sz="1600">
                           <a:latin typeface="Play"/>
                         </a:rPr>
-                        <a:t>Reference item 145</a:t>
+                        <a:t>Запись справочника 145</a:t>
                       </a:r>
                     </a:p>
                   </a:txBody>
@@ -21720,7 +21832,7 @@
                         <a:rPr sz="1600">
                           <a:latin typeface="Play"/>
                         </a:rPr>
-                        <a:t>Reference item 146</a:t>
+                        <a:t>Запись справочника 146</a:t>
                       </a:r>
                     </a:p>
                   </a:txBody>
@@ -21758,7 +21870,7 @@
                         <a:rPr sz="1600">
                           <a:latin typeface="Play"/>
                         </a:rPr>
-                        <a:t>Reference item 147</a:t>
+                        <a:t>Запись справочника 147</a:t>
                       </a:r>
                     </a:p>
                   </a:txBody>
@@ -21913,7 +22025,7 @@
                 </a:solidFill>
                 <a:latin typeface="Play"/>
               </a:rPr>
-              <a:t>Источник: reference_201.csv · 201 исходных строк</a:t>
+              <a:t>Источник: reference_201.csv</a:t>
             </a:r>
           </a:p>
           <a:p>
@@ -21924,7 +22036,7 @@
                 </a:solidFill>
                 <a:latin typeface="Play"/>
               </a:rPr>
-              <a:t>Охват: страница 21/29; строки источника 142–148 из 201; пропуски показаны как в источнике.</a:t>
+              <a:t>Охват: 201 из 201 строк; исключено: 0. Страница 21/29. Показано: 7.</a:t>
             </a:r>
           </a:p>
         </p:txBody>
@@ -22026,7 +22138,7 @@
                           </a:solidFill>
                           <a:latin typeface="Play"/>
                         </a:rPr>
-                        <a:t>reference_id</a:t>
+                        <a:t>Код записи</a:t>
                       </a:r>
                     </a:p>
                   </a:txBody>
@@ -22048,7 +22160,7 @@
                           </a:solidFill>
                           <a:latin typeface="Play"/>
                         </a:rPr>
-                        <a:t>label</a:t>
+                        <a:t>Наименование</a:t>
                       </a:r>
                     </a:p>
                   </a:txBody>
@@ -22088,7 +22200,7 @@
                         <a:rPr sz="1600">
                           <a:latin typeface="Play"/>
                         </a:rPr>
-                        <a:t>Reference item 148</a:t>
+                        <a:t>Запись справочника 148</a:t>
                       </a:r>
                     </a:p>
                   </a:txBody>
@@ -22126,7 +22238,7 @@
                         <a:rPr sz="1600">
                           <a:latin typeface="Play"/>
                         </a:rPr>
-                        <a:t>Reference item 149</a:t>
+                        <a:t>Запись справочника 149</a:t>
                       </a:r>
                     </a:p>
                   </a:txBody>
@@ -22164,7 +22276,7 @@
                         <a:rPr sz="1600">
                           <a:latin typeface="Play"/>
                         </a:rPr>
-                        <a:t>Reference item 150</a:t>
+                        <a:t>Запись справочника 150</a:t>
                       </a:r>
                     </a:p>
                   </a:txBody>
@@ -22202,7 +22314,7 @@
                         <a:rPr sz="1600">
                           <a:latin typeface="Play"/>
                         </a:rPr>
-                        <a:t>Reference item 151</a:t>
+                        <a:t>Запись справочника 151</a:t>
                       </a:r>
                     </a:p>
                   </a:txBody>
@@ -22240,7 +22352,7 @@
                         <a:rPr sz="1600">
                           <a:latin typeface="Play"/>
                         </a:rPr>
-                        <a:t>Reference item 152</a:t>
+                        <a:t>Запись справочника 152</a:t>
                       </a:r>
                     </a:p>
                   </a:txBody>
@@ -22278,7 +22390,7 @@
                         <a:rPr sz="1600">
                           <a:latin typeface="Play"/>
                         </a:rPr>
-                        <a:t>Reference item 153</a:t>
+                        <a:t>Запись справочника 153</a:t>
                       </a:r>
                     </a:p>
                   </a:txBody>
@@ -22316,7 +22428,7 @@
                         <a:rPr sz="1600">
                           <a:latin typeface="Play"/>
                         </a:rPr>
-                        <a:t>Reference item 154</a:t>
+                        <a:t>Запись справочника 154</a:t>
                       </a:r>
                     </a:p>
                   </a:txBody>
@@ -22471,7 +22583,7 @@
                 </a:solidFill>
                 <a:latin typeface="Play"/>
               </a:rPr>
-              <a:t>Источник: reference_201.csv · 201 исходных строк</a:t>
+              <a:t>Источник: reference_201.csv</a:t>
             </a:r>
           </a:p>
           <a:p>
@@ -22482,7 +22594,7 @@
                 </a:solidFill>
                 <a:latin typeface="Play"/>
               </a:rPr>
-              <a:t>Охват: страница 22/29; строки источника 149–155 из 201; пропуски показаны как в источнике.</a:t>
+              <a:t>Охват: 201 из 201 строк; исключено: 0. Страница 22/29. Показано: 7.</a:t>
             </a:r>
           </a:p>
         </p:txBody>
@@ -22584,7 +22696,7 @@
                           </a:solidFill>
                           <a:latin typeface="Play"/>
                         </a:rPr>
-                        <a:t>reference_id</a:t>
+                        <a:t>Код записи</a:t>
                       </a:r>
                     </a:p>
                   </a:txBody>
@@ -22606,7 +22718,7 @@
                           </a:solidFill>
                           <a:latin typeface="Play"/>
                         </a:rPr>
-                        <a:t>label</a:t>
+                        <a:t>Наименование</a:t>
                       </a:r>
                     </a:p>
                   </a:txBody>
@@ -22646,7 +22758,7 @@
                         <a:rPr sz="1600">
                           <a:latin typeface="Play"/>
                         </a:rPr>
-                        <a:t>Reference item 155</a:t>
+                        <a:t>Запись справочника 155</a:t>
                       </a:r>
                     </a:p>
                   </a:txBody>
@@ -22684,7 +22796,7 @@
                         <a:rPr sz="1600">
                           <a:latin typeface="Play"/>
                         </a:rPr>
-                        <a:t>Reference item 156</a:t>
+                        <a:t>Запись справочника 156</a:t>
                       </a:r>
                     </a:p>
                   </a:txBody>
@@ -22722,7 +22834,7 @@
                         <a:rPr sz="1600">
                           <a:latin typeface="Play"/>
                         </a:rPr>
-                        <a:t>Reference item 157</a:t>
+                        <a:t>Запись справочника 157</a:t>
                       </a:r>
                     </a:p>
                   </a:txBody>
@@ -22760,7 +22872,7 @@
                         <a:rPr sz="1600">
                           <a:latin typeface="Play"/>
                         </a:rPr>
-                        <a:t>Reference item 158</a:t>
+                        <a:t>Запись справочника 158</a:t>
                       </a:r>
                     </a:p>
                   </a:txBody>
@@ -22798,7 +22910,7 @@
                         <a:rPr sz="1600">
                           <a:latin typeface="Play"/>
                         </a:rPr>
-                        <a:t>Reference item 159</a:t>
+                        <a:t>Запись справочника 159</a:t>
                       </a:r>
                     </a:p>
                   </a:txBody>
@@ -22836,7 +22948,7 @@
                         <a:rPr sz="1600">
                           <a:latin typeface="Play"/>
                         </a:rPr>
-                        <a:t>Reference item 160</a:t>
+                        <a:t>Запись справочника 160</a:t>
                       </a:r>
                     </a:p>
                   </a:txBody>
@@ -22874,7 +22986,7 @@
                         <a:rPr sz="1600">
                           <a:latin typeface="Play"/>
                         </a:rPr>
-                        <a:t>Reference item 161</a:t>
+                        <a:t>Запись справочника 161</a:t>
                       </a:r>
                     </a:p>
                   </a:txBody>
@@ -23029,7 +23141,7 @@
                 </a:solidFill>
                 <a:latin typeface="Play"/>
               </a:rPr>
-              <a:t>Источник: reference_201.csv · 201 исходных строк</a:t>
+              <a:t>Источник: reference_201.csv</a:t>
             </a:r>
           </a:p>
           <a:p>
@@ -23040,7 +23152,7 @@
                 </a:solidFill>
                 <a:latin typeface="Play"/>
               </a:rPr>
-              <a:t>Охват: страница 23/29; строки источника 156–162 из 201; пропуски показаны как в источнике.</a:t>
+              <a:t>Охват: 201 из 201 строк; исключено: 0. Страница 23/29. Показано: 7.</a:t>
             </a:r>
           </a:p>
         </p:txBody>
@@ -23142,7 +23254,7 @@
                           </a:solidFill>
                           <a:latin typeface="Play"/>
                         </a:rPr>
-                        <a:t>reference_id</a:t>
+                        <a:t>Код записи</a:t>
                       </a:r>
                     </a:p>
                   </a:txBody>
@@ -23164,7 +23276,7 @@
                           </a:solidFill>
                           <a:latin typeface="Play"/>
                         </a:rPr>
-                        <a:t>label</a:t>
+                        <a:t>Наименование</a:t>
                       </a:r>
                     </a:p>
                   </a:txBody>
@@ -23204,7 +23316,7 @@
                         <a:rPr sz="1600">
                           <a:latin typeface="Play"/>
                         </a:rPr>
-                        <a:t>Reference item 162</a:t>
+                        <a:t>Запись справочника 162</a:t>
                       </a:r>
                     </a:p>
                   </a:txBody>
@@ -23242,7 +23354,7 @@
                         <a:rPr sz="1600">
                           <a:latin typeface="Play"/>
                         </a:rPr>
-                        <a:t>Reference item 163</a:t>
+                        <a:t>Запись справочника 163</a:t>
                       </a:r>
                     </a:p>
                   </a:txBody>
@@ -23280,7 +23392,7 @@
                         <a:rPr sz="1600">
                           <a:latin typeface="Play"/>
                         </a:rPr>
-                        <a:t>Reference item 164</a:t>
+                        <a:t>Запись справочника 164</a:t>
                       </a:r>
                     </a:p>
                   </a:txBody>
@@ -23318,7 +23430,7 @@
                         <a:rPr sz="1600">
                           <a:latin typeface="Play"/>
                         </a:rPr>
-                        <a:t>Reference item 165</a:t>
+                        <a:t>Запись справочника 165</a:t>
                       </a:r>
                     </a:p>
                   </a:txBody>
@@ -23356,7 +23468,7 @@
                         <a:rPr sz="1600">
                           <a:latin typeface="Play"/>
                         </a:rPr>
-                        <a:t>Reference item 166</a:t>
+                        <a:t>Запись справочника 166</a:t>
                       </a:r>
                     </a:p>
                   </a:txBody>
@@ -23394,7 +23506,7 @@
                         <a:rPr sz="1600">
                           <a:latin typeface="Play"/>
                         </a:rPr>
-                        <a:t>Reference item 167</a:t>
+                        <a:t>Запись справочника 167</a:t>
                       </a:r>
                     </a:p>
                   </a:txBody>
@@ -23432,7 +23544,7 @@
                         <a:rPr sz="1600">
                           <a:latin typeface="Play"/>
                         </a:rPr>
-                        <a:t>Reference item 168</a:t>
+                        <a:t>Запись справочника 168</a:t>
                       </a:r>
                     </a:p>
                   </a:txBody>
@@ -23587,7 +23699,7 @@
                 </a:solidFill>
                 <a:latin typeface="Play"/>
               </a:rPr>
-              <a:t>Источник: reference_201.csv · 201 исходных строк</a:t>
+              <a:t>Источник: reference_201.csv</a:t>
             </a:r>
           </a:p>
           <a:p>
@@ -23598,7 +23710,7 @@
                 </a:solidFill>
                 <a:latin typeface="Play"/>
               </a:rPr>
-              <a:t>Охват: страница 24/29; строки источника 163–169 из 201; пропуски показаны как в источнике.</a:t>
+              <a:t>Охват: 201 из 201 строк; исключено: 0. Страница 24/29. Показано: 7.</a:t>
             </a:r>
           </a:p>
         </p:txBody>
@@ -23700,7 +23812,7 @@
                           </a:solidFill>
                           <a:latin typeface="Play"/>
                         </a:rPr>
-                        <a:t>reference_id</a:t>
+                        <a:t>Код записи</a:t>
                       </a:r>
                     </a:p>
                   </a:txBody>
@@ -23722,7 +23834,7 @@
                           </a:solidFill>
                           <a:latin typeface="Play"/>
                         </a:rPr>
-                        <a:t>label</a:t>
+                        <a:t>Наименование</a:t>
                       </a:r>
                     </a:p>
                   </a:txBody>
@@ -23762,7 +23874,7 @@
                         <a:rPr sz="1600">
                           <a:latin typeface="Play"/>
                         </a:rPr>
-                        <a:t>Reference item 169</a:t>
+                        <a:t>Запись справочника 169</a:t>
                       </a:r>
                     </a:p>
                   </a:txBody>
@@ -23800,7 +23912,7 @@
                         <a:rPr sz="1600">
                           <a:latin typeface="Play"/>
                         </a:rPr>
-                        <a:t>Reference item 170</a:t>
+                        <a:t>Запись справочника 170</a:t>
                       </a:r>
                     </a:p>
                   </a:txBody>
@@ -23838,7 +23950,7 @@
                         <a:rPr sz="1600">
                           <a:latin typeface="Play"/>
                         </a:rPr>
-                        <a:t>Reference item 171</a:t>
+                        <a:t>Запись справочника 171</a:t>
                       </a:r>
                     </a:p>
                   </a:txBody>
@@ -23876,7 +23988,7 @@
                         <a:rPr sz="1600">
                           <a:latin typeface="Play"/>
                         </a:rPr>
-                        <a:t>Reference item 172</a:t>
+                        <a:t>Запись справочника 172</a:t>
                       </a:r>
                     </a:p>
                   </a:txBody>
@@ -23914,7 +24026,7 @@
                         <a:rPr sz="1600">
                           <a:latin typeface="Play"/>
                         </a:rPr>
-                        <a:t>Reference item 173</a:t>
+                        <a:t>Запись справочника 173</a:t>
                       </a:r>
                     </a:p>
                   </a:txBody>
@@ -23952,7 +24064,7 @@
                         <a:rPr sz="1600">
                           <a:latin typeface="Play"/>
                         </a:rPr>
-                        <a:t>Reference item 174</a:t>
+                        <a:t>Запись справочника 174</a:t>
                       </a:r>
                     </a:p>
                   </a:txBody>
@@ -23990,7 +24102,7 @@
                         <a:rPr sz="1600">
                           <a:latin typeface="Play"/>
                         </a:rPr>
-                        <a:t>Reference item 175</a:t>
+                        <a:t>Запись справочника 175</a:t>
                       </a:r>
                     </a:p>
                   </a:txBody>
@@ -24145,7 +24257,7 @@
                 </a:solidFill>
                 <a:latin typeface="Play"/>
               </a:rPr>
-              <a:t>Источник: reference_201.csv · 201 исходных строк</a:t>
+              <a:t>Источник: reference_201.csv</a:t>
             </a:r>
           </a:p>
           <a:p>
@@ -24156,7 +24268,7 @@
                 </a:solidFill>
                 <a:latin typeface="Play"/>
               </a:rPr>
-              <a:t>Охват: страница 25/29; строки источника 170–176 из 201; пропуски показаны как в источнике.</a:t>
+              <a:t>Охват: 201 из 201 строк; исключено: 0. Страница 25/29. Показано: 7.</a:t>
             </a:r>
           </a:p>
         </p:txBody>
@@ -24258,7 +24370,7 @@
                           </a:solidFill>
                           <a:latin typeface="Play"/>
                         </a:rPr>
-                        <a:t>reference_id</a:t>
+                        <a:t>Код записи</a:t>
                       </a:r>
                     </a:p>
                   </a:txBody>
@@ -24280,7 +24392,7 @@
                           </a:solidFill>
                           <a:latin typeface="Play"/>
                         </a:rPr>
-                        <a:t>label</a:t>
+                        <a:t>Наименование</a:t>
                       </a:r>
                     </a:p>
                   </a:txBody>
@@ -24320,7 +24432,7 @@
                         <a:rPr sz="1600">
                           <a:latin typeface="Play"/>
                         </a:rPr>
-                        <a:t>Reference item 176</a:t>
+                        <a:t>Запись справочника 176</a:t>
                       </a:r>
                     </a:p>
                   </a:txBody>
@@ -24358,7 +24470,7 @@
                         <a:rPr sz="1600">
                           <a:latin typeface="Play"/>
                         </a:rPr>
-                        <a:t>Reference item 177</a:t>
+                        <a:t>Запись справочника 177</a:t>
                       </a:r>
                     </a:p>
                   </a:txBody>
@@ -24396,7 +24508,7 @@
                         <a:rPr sz="1600">
                           <a:latin typeface="Play"/>
                         </a:rPr>
-                        <a:t>Reference item 178</a:t>
+                        <a:t>Запись справочника 178</a:t>
                       </a:r>
                     </a:p>
                   </a:txBody>
@@ -24434,7 +24546,7 @@
                         <a:rPr sz="1600">
                           <a:latin typeface="Play"/>
                         </a:rPr>
-                        <a:t>Reference item 179</a:t>
+                        <a:t>Запись справочника 179</a:t>
                       </a:r>
                     </a:p>
                   </a:txBody>
@@ -24472,7 +24584,7 @@
                         <a:rPr sz="1600">
                           <a:latin typeface="Play"/>
                         </a:rPr>
-                        <a:t>Reference item 180</a:t>
+                        <a:t>Запись справочника 180</a:t>
                       </a:r>
                     </a:p>
                   </a:txBody>
@@ -24510,7 +24622,7 @@
                         <a:rPr sz="1600">
                           <a:latin typeface="Play"/>
                         </a:rPr>
-                        <a:t>Reference item 181</a:t>
+                        <a:t>Запись справочника 181</a:t>
                       </a:r>
                     </a:p>
                   </a:txBody>
@@ -24548,7 +24660,7 @@
                         <a:rPr sz="1600">
                           <a:latin typeface="Play"/>
                         </a:rPr>
-                        <a:t>Reference item 182</a:t>
+                        <a:t>Запись справочника 182</a:t>
                       </a:r>
                     </a:p>
                   </a:txBody>
@@ -24703,7 +24815,7 @@
                 </a:solidFill>
                 <a:latin typeface="Play"/>
               </a:rPr>
-              <a:t>Источник: reference_201.csv · 201 исходных строк</a:t>
+              <a:t>Источник: reference_201.csv</a:t>
             </a:r>
           </a:p>
           <a:p>
@@ -24714,7 +24826,7 @@
                 </a:solidFill>
                 <a:latin typeface="Play"/>
               </a:rPr>
-              <a:t>Охват: страница 26/29; строки источника 177–183 из 201; пропуски показаны как в источнике.</a:t>
+              <a:t>Охват: 201 из 201 строк; исключено: 0. Страница 26/29. Показано: 7.</a:t>
             </a:r>
           </a:p>
         </p:txBody>
@@ -24816,7 +24928,7 @@
                           </a:solidFill>
                           <a:latin typeface="Play"/>
                         </a:rPr>
-                        <a:t>reference_id</a:t>
+                        <a:t>Код записи</a:t>
                       </a:r>
                     </a:p>
                   </a:txBody>
@@ -24838,7 +24950,7 @@
                           </a:solidFill>
                           <a:latin typeface="Play"/>
                         </a:rPr>
-                        <a:t>label</a:t>
+                        <a:t>Наименование</a:t>
                       </a:r>
                     </a:p>
                   </a:txBody>
@@ -24878,7 +24990,7 @@
                         <a:rPr sz="1600">
                           <a:latin typeface="Play"/>
                         </a:rPr>
-                        <a:t>Reference item 183</a:t>
+                        <a:t>Запись справочника 183</a:t>
                       </a:r>
                     </a:p>
                   </a:txBody>
@@ -24916,7 +25028,7 @@
                         <a:rPr sz="1600">
                           <a:latin typeface="Play"/>
                         </a:rPr>
-                        <a:t>Reference item 184</a:t>
+                        <a:t>Запись справочника 184</a:t>
                       </a:r>
                     </a:p>
                   </a:txBody>
@@ -24954,7 +25066,7 @@
                         <a:rPr sz="1600">
                           <a:latin typeface="Play"/>
                         </a:rPr>
-                        <a:t>Reference item 185</a:t>
+                        <a:t>Запись справочника 185</a:t>
                       </a:r>
                     </a:p>
                   </a:txBody>
@@ -24992,7 +25104,7 @@
                         <a:rPr sz="1600">
                           <a:latin typeface="Play"/>
                         </a:rPr>
-                        <a:t>Reference item 186</a:t>
+                        <a:t>Запись справочника 186</a:t>
                       </a:r>
                     </a:p>
                   </a:txBody>
@@ -25030,7 +25142,7 @@
                         <a:rPr sz="1600">
                           <a:latin typeface="Play"/>
                         </a:rPr>
-                        <a:t>Reference item 187</a:t>
+                        <a:t>Запись справочника 187</a:t>
                       </a:r>
                     </a:p>
                   </a:txBody>
@@ -25068,7 +25180,7 @@
                         <a:rPr sz="1600">
                           <a:latin typeface="Play"/>
                         </a:rPr>
-                        <a:t>Reference item 188</a:t>
+                        <a:t>Запись справочника 188</a:t>
                       </a:r>
                     </a:p>
                   </a:txBody>
@@ -25106,7 +25218,7 @@
                         <a:rPr sz="1600">
                           <a:latin typeface="Play"/>
                         </a:rPr>
-                        <a:t>Reference item 189</a:t>
+                        <a:t>Запись справочника 189</a:t>
                       </a:r>
                     </a:p>
                   </a:txBody>
@@ -25261,7 +25373,7 @@
                 </a:solidFill>
                 <a:latin typeface="Play"/>
               </a:rPr>
-              <a:t>Источник: reference_201.csv · 201 исходных строк</a:t>
+              <a:t>Источник: reference_201.csv</a:t>
             </a:r>
           </a:p>
           <a:p>
@@ -25272,7 +25384,7 @@
                 </a:solidFill>
                 <a:latin typeface="Play"/>
               </a:rPr>
-              <a:t>Охват: страница 27/29; строки источника 184–190 из 201; пропуски показаны как в источнике.</a:t>
+              <a:t>Охват: 201 из 201 строк; исключено: 0. Страница 27/29. Показано: 7.</a:t>
             </a:r>
           </a:p>
         </p:txBody>
@@ -25374,7 +25486,7 @@
                           </a:solidFill>
                           <a:latin typeface="Play"/>
                         </a:rPr>
-                        <a:t>reference_id</a:t>
+                        <a:t>Код записи</a:t>
                       </a:r>
                     </a:p>
                   </a:txBody>
@@ -25396,7 +25508,7 @@
                           </a:solidFill>
                           <a:latin typeface="Play"/>
                         </a:rPr>
-                        <a:t>label</a:t>
+                        <a:t>Наименование</a:t>
                       </a:r>
                     </a:p>
                   </a:txBody>
@@ -25436,7 +25548,7 @@
                         <a:rPr sz="1600">
                           <a:latin typeface="Play"/>
                         </a:rPr>
-                        <a:t>Reference item 190</a:t>
+                        <a:t>Запись справочника 190</a:t>
                       </a:r>
                     </a:p>
                   </a:txBody>
@@ -25474,7 +25586,7 @@
                         <a:rPr sz="1600">
                           <a:latin typeface="Play"/>
                         </a:rPr>
-                        <a:t>Reference item 191</a:t>
+                        <a:t>Запись справочника 191</a:t>
                       </a:r>
                     </a:p>
                   </a:txBody>
@@ -25512,7 +25624,7 @@
                         <a:rPr sz="1600">
                           <a:latin typeface="Play"/>
                         </a:rPr>
-                        <a:t>Reference item 192</a:t>
+                        <a:t>Запись справочника 192</a:t>
                       </a:r>
                     </a:p>
                   </a:txBody>
@@ -25550,7 +25662,7 @@
                         <a:rPr sz="1600">
                           <a:latin typeface="Play"/>
                         </a:rPr>
-                        <a:t>Reference item 193</a:t>
+                        <a:t>Запись справочника 193</a:t>
                       </a:r>
                     </a:p>
                   </a:txBody>
@@ -25588,7 +25700,7 @@
                         <a:rPr sz="1600">
                           <a:latin typeface="Play"/>
                         </a:rPr>
-                        <a:t>Reference item 194</a:t>
+                        <a:t>Запись справочника 194</a:t>
                       </a:r>
                     </a:p>
                   </a:txBody>
@@ -25626,7 +25738,7 @@
                         <a:rPr sz="1600">
                           <a:latin typeface="Play"/>
                         </a:rPr>
-                        <a:t>Reference item 195</a:t>
+                        <a:t>Запись справочника 195</a:t>
                       </a:r>
                     </a:p>
                   </a:txBody>
@@ -25664,7 +25776,7 @@
                         <a:rPr sz="1600">
                           <a:latin typeface="Play"/>
                         </a:rPr>
-                        <a:t>Reference item 196</a:t>
+                        <a:t>Запись справочника 196</a:t>
                       </a:r>
                     </a:p>
                   </a:txBody>
@@ -25819,7 +25931,7 @@
                 </a:solidFill>
                 <a:latin typeface="Play"/>
               </a:rPr>
-              <a:t>Источник: reference_201.csv · 201 исходных строк</a:t>
+              <a:t>Источник: reference_201.csv</a:t>
             </a:r>
           </a:p>
           <a:p>
@@ -25830,7 +25942,7 @@
                 </a:solidFill>
                 <a:latin typeface="Play"/>
               </a:rPr>
-              <a:t>Охват: страница 28/29; строки источника 191–197 из 201; пропуски показаны как в источнике.</a:t>
+              <a:t>Охват: 201 из 201 строк; исключено: 0. Страница 28/29. Показано: 7.</a:t>
             </a:r>
           </a:p>
         </p:txBody>
@@ -25932,7 +26044,7 @@
                           </a:solidFill>
                           <a:latin typeface="Play"/>
                         </a:rPr>
-                        <a:t>reference_id</a:t>
+                        <a:t>Код записи</a:t>
                       </a:r>
                     </a:p>
                   </a:txBody>
@@ -25954,7 +26066,7 @@
                           </a:solidFill>
                           <a:latin typeface="Play"/>
                         </a:rPr>
-                        <a:t>label</a:t>
+                        <a:t>Наименование</a:t>
                       </a:r>
                     </a:p>
                   </a:txBody>
@@ -25994,7 +26106,7 @@
                         <a:rPr sz="1600">
                           <a:latin typeface="Play"/>
                         </a:rPr>
-                        <a:t>Reference item 197</a:t>
+                        <a:t>Запись справочника 197</a:t>
                       </a:r>
                     </a:p>
                   </a:txBody>
@@ -26032,7 +26144,7 @@
                         <a:rPr sz="1600">
                           <a:latin typeface="Play"/>
                         </a:rPr>
-                        <a:t>Reference item 198</a:t>
+                        <a:t>Запись справочника 198</a:t>
                       </a:r>
                     </a:p>
                   </a:txBody>
@@ -26070,7 +26182,7 @@
                         <a:rPr sz="1600">
                           <a:latin typeface="Play"/>
                         </a:rPr>
-                        <a:t>Reference item 199</a:t>
+                        <a:t>Запись справочника 199</a:t>
                       </a:r>
                     </a:p>
                   </a:txBody>
@@ -26108,7 +26220,7 @@
                         <a:rPr sz="1600">
                           <a:latin typeface="Play"/>
                         </a:rPr>
-                        <a:t>Reference item 200</a:t>
+                        <a:t>Запись справочника 200</a:t>
                       </a:r>
                     </a:p>
                   </a:txBody>
@@ -26146,7 +26258,7 @@
                         <a:rPr sz="1600">
                           <a:latin typeface="Play"/>
                         </a:rPr>
-                        <a:t>Reference item 201</a:t>
+                        <a:t>Запись справочника 201</a:t>
                       </a:r>
                     </a:p>
                   </a:txBody>
@@ -26301,7 +26413,7 @@
                 </a:solidFill>
                 <a:latin typeface="Play"/>
               </a:rPr>
-              <a:t>Источник: reference_201.csv · 201 исходных строк</a:t>
+              <a:t>Источник: reference_201.csv</a:t>
             </a:r>
           </a:p>
           <a:p>
@@ -26312,7 +26424,7 @@
                 </a:solidFill>
                 <a:latin typeface="Play"/>
               </a:rPr>
-              <a:t>Охват: страница 29/29; строки источника 198–202 из 201; пропуски показаны как в источнике.</a:t>
+              <a:t>Охват: 201 из 201 строк; исключено: 0. Страница 29/29. Показано: 5.</a:t>
             </a:r>
           </a:p>
         </p:txBody>

</xml_diff>